<commit_message>
Clarify aliasing versus Fourier bases in SAR materials
</commit_message>
<xml_diff>
--- a/assets/presentations/study/speech-and-audio-recognition/sar-midterm-review-slides.pptx
+++ b/assets/presentations/study/speech-and-audio-recognition/sar-midterm-review-slides.pptx
@@ -2,37 +2,37 @@
 <file path=ppt/presentation.xml><?xml version="1.0" encoding="utf-8"?>
 <p:presentation xmlns:p="http://schemas.openxmlformats.org/presentationml/2006/main">
   <p:sldMasterIdLst>
-    <p:sldMasterId xmlns:r="http://schemas.openxmlformats.org/officeDocument/2006/relationships" id="2147483648" r:id="R61137b4e60c44316"/>
+    <p:sldMasterId xmlns:r="http://schemas.openxmlformats.org/officeDocument/2006/relationships" id="2147483648" r:id="R37df640ea12e45af"/>
   </p:sldMasterIdLst>
   <p:notesMasterIdLst>
-    <p:notesMasterId xmlns:r="http://schemas.openxmlformats.org/officeDocument/2006/relationships" r:id="Rb44e7a93041b4d43"/>
+    <p:notesMasterId xmlns:r="http://schemas.openxmlformats.org/officeDocument/2006/relationships" r:id="R2ab629552b73418c"/>
   </p:notesMasterIdLst>
   <p:sldIdLst>
-    <p:sldId xmlns:r="http://schemas.openxmlformats.org/officeDocument/2006/relationships" id="256" r:id="Rf8ad3c18f76c4297"/>
-    <p:sldId xmlns:r="http://schemas.openxmlformats.org/officeDocument/2006/relationships" id="257" r:id="R81ecba7624de48f5"/>
-    <p:sldId xmlns:r="http://schemas.openxmlformats.org/officeDocument/2006/relationships" id="258" r:id="R130d8159be3045a2"/>
-    <p:sldId xmlns:r="http://schemas.openxmlformats.org/officeDocument/2006/relationships" id="259" r:id="R181f34fece0f4672"/>
-    <p:sldId xmlns:r="http://schemas.openxmlformats.org/officeDocument/2006/relationships" id="260" r:id="R770e598ee6104971"/>
-    <p:sldId xmlns:r="http://schemas.openxmlformats.org/officeDocument/2006/relationships" id="261" r:id="R58b94bfcde814dd4"/>
-    <p:sldId xmlns:r="http://schemas.openxmlformats.org/officeDocument/2006/relationships" id="262" r:id="Rb006a91f98c74ad7"/>
-    <p:sldId xmlns:r="http://schemas.openxmlformats.org/officeDocument/2006/relationships" id="263" r:id="Recb99d2617a94ea1"/>
-    <p:sldId xmlns:r="http://schemas.openxmlformats.org/officeDocument/2006/relationships" id="264" r:id="R29cb6cfc160246c5"/>
-    <p:sldId xmlns:r="http://schemas.openxmlformats.org/officeDocument/2006/relationships" id="265" r:id="R21e96c7755ea4f9d"/>
-    <p:sldId xmlns:r="http://schemas.openxmlformats.org/officeDocument/2006/relationships" id="266" r:id="Rcd293b3ef9624e27"/>
-    <p:sldId xmlns:r="http://schemas.openxmlformats.org/officeDocument/2006/relationships" id="267" r:id="R7fd29b9d3e3348da"/>
-    <p:sldId xmlns:r="http://schemas.openxmlformats.org/officeDocument/2006/relationships" id="268" r:id="R43160ada619d4d47"/>
-    <p:sldId xmlns:r="http://schemas.openxmlformats.org/officeDocument/2006/relationships" id="269" r:id="Rc86d1436b2a44685"/>
-    <p:sldId xmlns:r="http://schemas.openxmlformats.org/officeDocument/2006/relationships" id="270" r:id="Rd8a7ee32c36149cd"/>
-    <p:sldId xmlns:r="http://schemas.openxmlformats.org/officeDocument/2006/relationships" id="271" r:id="R4524f05fc6384192"/>
-    <p:sldId xmlns:r="http://schemas.openxmlformats.org/officeDocument/2006/relationships" id="272" r:id="R36b3052c17944f3a"/>
-    <p:sldId xmlns:r="http://schemas.openxmlformats.org/officeDocument/2006/relationships" id="273" r:id="R26e65fd512a44a51"/>
-    <p:sldId xmlns:r="http://schemas.openxmlformats.org/officeDocument/2006/relationships" id="274" r:id="R58c9bb32a0a24800"/>
-    <p:sldId xmlns:r="http://schemas.openxmlformats.org/officeDocument/2006/relationships" id="275" r:id="Rf9d6557e173b4ef3"/>
-    <p:sldId xmlns:r="http://schemas.openxmlformats.org/officeDocument/2006/relationships" id="276" r:id="Rc9841119e1934d61"/>
-    <p:sldId xmlns:r="http://schemas.openxmlformats.org/officeDocument/2006/relationships" id="277" r:id="Rf3fe7f560b2540d2"/>
-    <p:sldId xmlns:r="http://schemas.openxmlformats.org/officeDocument/2006/relationships" id="278" r:id="Raeb780d6c93440ae"/>
-    <p:sldId xmlns:r="http://schemas.openxmlformats.org/officeDocument/2006/relationships" id="279" r:id="R505f45b9a0d54497"/>
-    <p:sldId xmlns:r="http://schemas.openxmlformats.org/officeDocument/2006/relationships" id="280" r:id="R1911e24d05474598"/>
+    <p:sldId xmlns:r="http://schemas.openxmlformats.org/officeDocument/2006/relationships" id="256" r:id="Rd2fca64957ef4ed4"/>
+    <p:sldId xmlns:r="http://schemas.openxmlformats.org/officeDocument/2006/relationships" id="257" r:id="R31b0baf7c90c441c"/>
+    <p:sldId xmlns:r="http://schemas.openxmlformats.org/officeDocument/2006/relationships" id="258" r:id="R48b06026b2f24043"/>
+    <p:sldId xmlns:r="http://schemas.openxmlformats.org/officeDocument/2006/relationships" id="259" r:id="R198b0199f51e494f"/>
+    <p:sldId xmlns:r="http://schemas.openxmlformats.org/officeDocument/2006/relationships" id="260" r:id="Rc9e519e26ba84d2f"/>
+    <p:sldId xmlns:r="http://schemas.openxmlformats.org/officeDocument/2006/relationships" id="261" r:id="Rc9e3d89c357e49fe"/>
+    <p:sldId xmlns:r="http://schemas.openxmlformats.org/officeDocument/2006/relationships" id="262" r:id="R5ddf82701d644833"/>
+    <p:sldId xmlns:r="http://schemas.openxmlformats.org/officeDocument/2006/relationships" id="263" r:id="Ra33c23ebea5e49a3"/>
+    <p:sldId xmlns:r="http://schemas.openxmlformats.org/officeDocument/2006/relationships" id="264" r:id="Re4db8f739f19477a"/>
+    <p:sldId xmlns:r="http://schemas.openxmlformats.org/officeDocument/2006/relationships" id="265" r:id="Rbadf211e37bb481b"/>
+    <p:sldId xmlns:r="http://schemas.openxmlformats.org/officeDocument/2006/relationships" id="266" r:id="R03cc2b98b3d74d6e"/>
+    <p:sldId xmlns:r="http://schemas.openxmlformats.org/officeDocument/2006/relationships" id="267" r:id="Rf2b6978393d64ccd"/>
+    <p:sldId xmlns:r="http://schemas.openxmlformats.org/officeDocument/2006/relationships" id="268" r:id="R32dff2438a304185"/>
+    <p:sldId xmlns:r="http://schemas.openxmlformats.org/officeDocument/2006/relationships" id="269" r:id="Ra7fad2853b6e46ed"/>
+    <p:sldId xmlns:r="http://schemas.openxmlformats.org/officeDocument/2006/relationships" id="270" r:id="Rb2c832c751ae426e"/>
+    <p:sldId xmlns:r="http://schemas.openxmlformats.org/officeDocument/2006/relationships" id="271" r:id="R23f98b1f353f4763"/>
+    <p:sldId xmlns:r="http://schemas.openxmlformats.org/officeDocument/2006/relationships" id="272" r:id="R9a2172d49c6146d8"/>
+    <p:sldId xmlns:r="http://schemas.openxmlformats.org/officeDocument/2006/relationships" id="273" r:id="R84028c8be1634b59"/>
+    <p:sldId xmlns:r="http://schemas.openxmlformats.org/officeDocument/2006/relationships" id="274" r:id="R5c0ed2a0cdc74e5c"/>
+    <p:sldId xmlns:r="http://schemas.openxmlformats.org/officeDocument/2006/relationships" id="275" r:id="R4e813f9d6cb14243"/>
+    <p:sldId xmlns:r="http://schemas.openxmlformats.org/officeDocument/2006/relationships" id="276" r:id="R9431559fd8c34ce9"/>
+    <p:sldId xmlns:r="http://schemas.openxmlformats.org/officeDocument/2006/relationships" id="277" r:id="R4d5763aa6c894722"/>
+    <p:sldId xmlns:r="http://schemas.openxmlformats.org/officeDocument/2006/relationships" id="278" r:id="Rff54d8e0f6464dd4"/>
+    <p:sldId xmlns:r="http://schemas.openxmlformats.org/officeDocument/2006/relationships" id="279" r:id="Rffee95e1252b4e76"/>
+    <p:sldId xmlns:r="http://schemas.openxmlformats.org/officeDocument/2006/relationships" id="280" r:id="R948ea34fe88d4eda"/>
   </p:sldIdLst>
   <p:sldSz cx="12192000" cy="6858000"/>
   <p:notesSz cx="6858000" cy="9144000"/>
@@ -1799,6 +1799,11 @@
               <a:t>원본: https://hyeonwoona0861.github.io/assets/pdfs/study/speech-and-audio-recognition/speech-audio-lecture-02.pdf#page=37 ; 캡처: https://hyeonwoona0861.github.io/assets/images/study/speech-and-audio-recognition/source-captures/speech-02-p37.png</a:t>
             </a:r>
           </a:p>
+          <a:p xmlns:a="http://schemas.openxmlformats.org/drawingml/2006/main">
+            <a:r>
+              <a:t>수식 검산: x_f[n]=exp(j2πfn/fs)일 때 어떤 정수 k에 대해 x_(f+kfs)[n]=x_f[n]이다. 복소 basis에서 5 kHz는 -3 kHz와 같은 표본이고, 실수 cosine의 짝수 대칭 때문에 zero-phase 3 kHz cosine과도 같다. 따라서 Fourier analysis는 겹침을 드러내지만 표본화 이후에 원래 성분을 재생성하지 못한다. 방지는 표본화 전 anti-alias low-pass filter와 필요 대역보다 충분히 높은 sampling rate로 한다.</a:t>
+            </a:r>
+          </a:p>
         </p:txBody>
       </p:sp>
       <p:sp>
@@ -1867,6 +1872,11 @@
           <a:p xmlns:a="http://schemas.openxmlformats.org/drawingml/2006/main">
             <a:r>
               <a:t>원본: https://hyeonwoona0861.github.io/assets/pdfs/study/speech-and-audio-recognition/speech-audio-lecture-02.pdf#page=26 ; 캡처: https://hyeonwoona0861.github.io/assets/images/study/speech-and-audio-recognition/source-captures/speech-02-p26.png</a:t>
+            </a:r>
+          </a:p>
+          <a:p xmlns:a="http://schemas.openxmlformats.org/drawingml/2006/main">
+            <a:r>
+              <a:t>이산 시간에서 exp(j2π(k+qN)n/N)=exp(j2πkn/N)이므로 basis index는 modulo N로 같아진다. DFT bin의 직교성은 0,…,N-1의 서로 다른 나머지 class에 대해 성립한다. 이 직교성은 관측된 표본 안의 성분을 분리하지만, aliasing으로 같은 class에 접힌 원래 아날로그 주파수까지 구별하지는 못한다.</a:t>
             </a:r>
           </a:p>
         </p:txBody>
@@ -2193,7 +2203,7 @@
           <p:cNvPr id="3" name="Title">
             <a:extLst xmlns:a="http://schemas.openxmlformats.org/drawingml/2006/main">
               <a:ext uri="{FF2B5EF4-FFF2-40B4-BE49-F238E27FC236}">
-                <a16:creationId xmlns:a16="http://schemas.microsoft.com/office/drawing/2014/main" id="{26B91F2C-91BA-4A2C-8E83-627CFF9E383C}"/>
+                <a16:creationId xmlns:a16="http://schemas.microsoft.com/office/drawing/2014/main" id="{E9C34A2E-68B1-4529-856D-13C3462B5AA7}"/>
               </a:ext>
             </a:extLst>
           </p:cNvPr>
@@ -2422,7 +2432,7 @@
           <p:cNvPr id="2" name="Subtitle">
             <a:extLst xmlns:a="http://schemas.openxmlformats.org/drawingml/2006/main">
               <a:ext uri="{FF2B5EF4-FFF2-40B4-BE49-F238E27FC236}">
-                <a16:creationId xmlns:a16="http://schemas.microsoft.com/office/drawing/2014/main" id="{DF6AC3BF-5DB7-4D1B-B9CC-25DDF822A734}"/>
+                <a16:creationId xmlns:a16="http://schemas.microsoft.com/office/drawing/2014/main" id="{596E95A3-F4CE-4596-82B0-F963D9232B45}"/>
               </a:ext>
             </a:extLst>
           </p:cNvPr>
@@ -2668,7 +2678,7 @@
           <p:cNvPr id="2" name="Section title">
             <a:extLst xmlns:a="http://schemas.openxmlformats.org/drawingml/2006/main">
               <a:ext uri="{FF2B5EF4-FFF2-40B4-BE49-F238E27FC236}">
-                <a16:creationId xmlns:a16="http://schemas.microsoft.com/office/drawing/2014/main" id="{DC809AEF-0227-4ABF-8F06-B1A8FD34471D}"/>
+                <a16:creationId xmlns:a16="http://schemas.microsoft.com/office/drawing/2014/main" id="{1151959F-6E0E-4653-8431-2A73697EE3F9}"/>
               </a:ext>
             </a:extLst>
           </p:cNvPr>
@@ -2914,7 +2924,7 @@
           <p:cNvPr id="3" name="Title">
             <a:extLst xmlns:a="http://schemas.openxmlformats.org/drawingml/2006/main">
               <a:ext uri="{FF2B5EF4-FFF2-40B4-BE49-F238E27FC236}">
-                <a16:creationId xmlns:a16="http://schemas.microsoft.com/office/drawing/2014/main" id="{AEC86F51-85F1-4767-A420-28276456EE80}"/>
+                <a16:creationId xmlns:a16="http://schemas.microsoft.com/office/drawing/2014/main" id="{8AA1CA48-A027-4CE6-AAB9-286DD517EB46}"/>
               </a:ext>
             </a:extLst>
           </p:cNvPr>
@@ -3143,7 +3153,7 @@
           <p:cNvPr id="2" name="Body">
             <a:extLst xmlns:a="http://schemas.openxmlformats.org/drawingml/2006/main">
               <a:ext uri="{FF2B5EF4-FFF2-40B4-BE49-F238E27FC236}">
-                <a16:creationId xmlns:a16="http://schemas.microsoft.com/office/drawing/2014/main" id="{144979FF-F181-42D7-9B4A-AC2EDFCD3703}"/>
+                <a16:creationId xmlns:a16="http://schemas.microsoft.com/office/drawing/2014/main" id="{85097B6B-67DB-4C78-A5F8-49C22F926B37}"/>
               </a:ext>
             </a:extLst>
           </p:cNvPr>
@@ -3389,7 +3399,7 @@
           <p:cNvPr id="4" name="Title">
             <a:extLst xmlns:a="http://schemas.openxmlformats.org/drawingml/2006/main">
               <a:ext uri="{FF2B5EF4-FFF2-40B4-BE49-F238E27FC236}">
-                <a16:creationId xmlns:a16="http://schemas.microsoft.com/office/drawing/2014/main" id="{B74DB825-BCBC-4F40-8FBB-C4E2FA8BE8A2}"/>
+                <a16:creationId xmlns:a16="http://schemas.microsoft.com/office/drawing/2014/main" id="{E7913F43-57EB-41A8-B539-0E5AA41D1A95}"/>
               </a:ext>
             </a:extLst>
           </p:cNvPr>
@@ -3618,7 +3628,7 @@
           <p:cNvPr id="2" name="Left column">
             <a:extLst xmlns:a="http://schemas.openxmlformats.org/drawingml/2006/main">
               <a:ext uri="{FF2B5EF4-FFF2-40B4-BE49-F238E27FC236}">
-                <a16:creationId xmlns:a16="http://schemas.microsoft.com/office/drawing/2014/main" id="{803612E5-4096-48E2-92C2-B0A391483774}"/>
+                <a16:creationId xmlns:a16="http://schemas.microsoft.com/office/drawing/2014/main" id="{468911F1-5161-4171-B557-D5170927CE8B}"/>
               </a:ext>
             </a:extLst>
           </p:cNvPr>
@@ -3847,7 +3857,7 @@
           <p:cNvPr id="3" name="Right column">
             <a:extLst xmlns:a="http://schemas.openxmlformats.org/drawingml/2006/main">
               <a:ext uri="{FF2B5EF4-FFF2-40B4-BE49-F238E27FC236}">
-                <a16:creationId xmlns:a16="http://schemas.microsoft.com/office/drawing/2014/main" id="{E65BCA06-A3BE-4ECC-ACEC-99204B5AF4FE}"/>
+                <a16:creationId xmlns:a16="http://schemas.microsoft.com/office/drawing/2014/main" id="{641342C8-91E7-44B9-ACE1-3DB8E8A7FA12}"/>
               </a:ext>
             </a:extLst>
           </p:cNvPr>
@@ -4093,7 +4103,7 @@
           <p:cNvPr id="3" name="Title">
             <a:extLst xmlns:a="http://schemas.openxmlformats.org/drawingml/2006/main">
               <a:ext uri="{FF2B5EF4-FFF2-40B4-BE49-F238E27FC236}">
-                <a16:creationId xmlns:a16="http://schemas.microsoft.com/office/drawing/2014/main" id="{40E880A6-5E84-4A5E-BF1B-190BA0724210}"/>
+                <a16:creationId xmlns:a16="http://schemas.microsoft.com/office/drawing/2014/main" id="{657A4230-7AAD-4705-8004-F2B211162396}"/>
               </a:ext>
             </a:extLst>
           </p:cNvPr>
@@ -4322,7 +4332,7 @@
           <p:cNvPr id="2" name="Left column">
             <a:extLst xmlns:a="http://schemas.openxmlformats.org/drawingml/2006/main">
               <a:ext uri="{FF2B5EF4-FFF2-40B4-BE49-F238E27FC236}">
-                <a16:creationId xmlns:a16="http://schemas.microsoft.com/office/drawing/2014/main" id="{DD223798-9AFA-4828-A027-DACA9F975016}"/>
+                <a16:creationId xmlns:a16="http://schemas.microsoft.com/office/drawing/2014/main" id="{4F01C46B-F743-459A-9A12-86A2AC78FDE5}"/>
               </a:ext>
             </a:extLst>
           </p:cNvPr>
@@ -4589,12 +4599,12 @@
   </p:cSld>
   <p:clrMap bg1="lt1" tx1="dk1" bg2="lt2" tx2="dk2" accent1="accent1" accent2="accent2" accent3="accent3" accent4="accent4" accent5="accent5" accent6="accent6" hlink="hlink" folHlink="folHlink"/>
   <p:sldLayoutIdLst>
-    <p:sldLayoutId xmlns:r="http://schemas.openxmlformats.org/officeDocument/2006/relationships" id="2147483649" r:id="Ra3510a7cb57b4514"/>
-    <p:sldLayoutId xmlns:r="http://schemas.openxmlformats.org/officeDocument/2006/relationships" id="2147483650" r:id="Rd59a7946107f4450"/>
-    <p:sldLayoutId xmlns:r="http://schemas.openxmlformats.org/officeDocument/2006/relationships" id="2147483651" r:id="R157cfe4df35040b7"/>
-    <p:sldLayoutId xmlns:r="http://schemas.openxmlformats.org/officeDocument/2006/relationships" id="2147483652" r:id="Rba2ff06afd484403"/>
-    <p:sldLayoutId xmlns:r="http://schemas.openxmlformats.org/officeDocument/2006/relationships" id="2147483653" r:id="Rba092144e1284430"/>
-    <p:sldLayoutId xmlns:r="http://schemas.openxmlformats.org/officeDocument/2006/relationships" id="2147483654" r:id="R991e5a4dbbf5464b"/>
+    <p:sldLayoutId xmlns:r="http://schemas.openxmlformats.org/officeDocument/2006/relationships" id="2147483649" r:id="R9e660a5bcd5a490b"/>
+    <p:sldLayoutId xmlns:r="http://schemas.openxmlformats.org/officeDocument/2006/relationships" id="2147483650" r:id="Rb48c3a3e66ce4bb3"/>
+    <p:sldLayoutId xmlns:r="http://schemas.openxmlformats.org/officeDocument/2006/relationships" id="2147483651" r:id="Rf46bba4642264312"/>
+    <p:sldLayoutId xmlns:r="http://schemas.openxmlformats.org/officeDocument/2006/relationships" id="2147483652" r:id="R0b627da96bdd4ef4"/>
+    <p:sldLayoutId xmlns:r="http://schemas.openxmlformats.org/officeDocument/2006/relationships" id="2147483653" r:id="R88778738a0104ef1"/>
+    <p:sldLayoutId xmlns:r="http://schemas.openxmlformats.org/officeDocument/2006/relationships" id="2147483654" r:id="R7334afd613694201"/>
   </p:sldLayoutIdLst>
   <p:txStyles>
     <p:titleStyle>
@@ -5145,7 +5155,7 @@
           <p:cNvPr id="6" name="">
             <a:extLst xmlns:a="http://schemas.openxmlformats.org/drawingml/2006/main">
               <a:ext uri="{FF2B5EF4-FFF2-40B4-BE49-F238E27FC236}">
-                <a16:creationId xmlns:a16="http://schemas.microsoft.com/office/drawing/2014/main" id="{EF39125F-A212-443C-AAEB-89110EEFF93E}"/>
+                <a16:creationId xmlns:a16="http://schemas.microsoft.com/office/drawing/2014/main" id="{3A36E7E7-269D-47F2-8A68-30843939FEAC}"/>
               </a:ext>
             </a:extLst>
           </p:cNvPr>
@@ -5303,7 +5313,7 @@
           <p:cNvPr id="2" name="">
             <a:extLst xmlns:a="http://schemas.openxmlformats.org/drawingml/2006/main">
               <a:ext uri="{FF2B5EF4-FFF2-40B4-BE49-F238E27FC236}">
-                <a16:creationId xmlns:a16="http://schemas.microsoft.com/office/drawing/2014/main" id="{162E6314-E47D-434F-BEF8-E59B100618E4}"/>
+                <a16:creationId xmlns:a16="http://schemas.microsoft.com/office/drawing/2014/main" id="{94A32D6F-714B-405C-B854-8149A3500890}"/>
               </a:ext>
             </a:extLst>
           </p:cNvPr>
@@ -5461,7 +5471,7 @@
           <p:cNvPr id="3" name="">
             <a:extLst xmlns:a="http://schemas.openxmlformats.org/drawingml/2006/main">
               <a:ext uri="{FF2B5EF4-FFF2-40B4-BE49-F238E27FC236}">
-                <a16:creationId xmlns:a16="http://schemas.microsoft.com/office/drawing/2014/main" id="{5E948112-FFFC-4968-9925-A3791C76AC29}"/>
+                <a16:creationId xmlns:a16="http://schemas.microsoft.com/office/drawing/2014/main" id="{8F70CCFA-1286-4568-8172-DF89CFFF0348}"/>
               </a:ext>
             </a:extLst>
           </p:cNvPr>
@@ -5619,7 +5629,7 @@
           <p:cNvPr id="4" name="">
             <a:extLst xmlns:a="http://schemas.openxmlformats.org/drawingml/2006/main">
               <a:ext uri="{FF2B5EF4-FFF2-40B4-BE49-F238E27FC236}">
-                <a16:creationId xmlns:a16="http://schemas.microsoft.com/office/drawing/2014/main" id="{2701E80D-E7FA-42AC-9373-B695EACDBD44}"/>
+                <a16:creationId xmlns:a16="http://schemas.microsoft.com/office/drawing/2014/main" id="{E44E03DA-C9E1-46C0-AF59-C157B5BBC085}"/>
               </a:ext>
             </a:extLst>
           </p:cNvPr>
@@ -5800,7 +5810,7 @@
           <p:cNvPr id="5" name="">
             <a:extLst xmlns:a="http://schemas.openxmlformats.org/drawingml/2006/main">
               <a:ext uri="{FF2B5EF4-FFF2-40B4-BE49-F238E27FC236}">
-                <a16:creationId xmlns:a16="http://schemas.microsoft.com/office/drawing/2014/main" id="{F88B2F12-C58A-4A8B-A759-4619B9F18223}"/>
+                <a16:creationId xmlns:a16="http://schemas.microsoft.com/office/drawing/2014/main" id="{660560C4-01B5-42BF-A9DD-673EA0CBC46F}"/>
               </a:ext>
             </a:extLst>
           </p:cNvPr>
@@ -5956,7 +5966,7 @@
     </p:spTree>
     <p:extLst>
       <p:ext uri="{BB962C8B-B14F-4D97-AF65-F5344CB8AC3E}">
-        <p14:creationId xmlns:p14="http://schemas.microsoft.com/office/powerpoint/2010/main" val="1535512122"/>
+        <p14:creationId xmlns:p14="http://schemas.microsoft.com/office/powerpoint/2010/main" val="164486104"/>
       </p:ext>
     </p:extLst>
   </p:cSld>
@@ -5987,7 +5997,7 @@
           <p:cNvPr id="7" name="">
             <a:extLst xmlns:a="http://schemas.openxmlformats.org/drawingml/2006/main">
               <a:ext uri="{FF2B5EF4-FFF2-40B4-BE49-F238E27FC236}">
-                <a16:creationId xmlns:a16="http://schemas.microsoft.com/office/drawing/2014/main" id="{78FFF15A-D20B-4223-8A94-B718EDC4A578}"/>
+                <a16:creationId xmlns:a16="http://schemas.microsoft.com/office/drawing/2014/main" id="{157AB114-944C-4DE0-9C8C-B14F9BE11E0A}"/>
               </a:ext>
             </a:extLst>
           </p:cNvPr>
@@ -6145,7 +6155,7 @@
           <p:cNvPr id="2" name="">
             <a:extLst xmlns:a="http://schemas.openxmlformats.org/drawingml/2006/main">
               <a:ext uri="{FF2B5EF4-FFF2-40B4-BE49-F238E27FC236}">
-                <a16:creationId xmlns:a16="http://schemas.microsoft.com/office/drawing/2014/main" id="{1959D605-B1F7-4D3D-A2A6-C6E8E7AD6935}"/>
+                <a16:creationId xmlns:a16="http://schemas.microsoft.com/office/drawing/2014/main" id="{C99BC719-8E1F-49C0-B480-D7FB19D00C08}"/>
               </a:ext>
             </a:extLst>
           </p:cNvPr>
@@ -6303,7 +6313,7 @@
           <p:cNvPr id="3" name="">
             <a:extLst xmlns:a="http://schemas.openxmlformats.org/drawingml/2006/main">
               <a:ext uri="{FF2B5EF4-FFF2-40B4-BE49-F238E27FC236}">
-                <a16:creationId xmlns:a16="http://schemas.microsoft.com/office/drawing/2014/main" id="{A8B6F1A1-07C8-4592-B7AD-356BBBBE60F9}"/>
+                <a16:creationId xmlns:a16="http://schemas.microsoft.com/office/drawing/2014/main" id="{1306059C-5E2F-441E-A78C-D9CF8A8815F1}"/>
               </a:ext>
             </a:extLst>
           </p:cNvPr>
@@ -6313,7 +6323,7 @@
           <p:nvPr/>
         </p:nvPicPr>
         <p:blipFill>
-          <a:blip xmlns:r="http://schemas.openxmlformats.org/officeDocument/2006/relationships" xmlns:a="http://schemas.openxmlformats.org/drawingml/2006/main" r:embed="R0e2c456b833048e9"/>
+          <a:blip xmlns:r="http://schemas.openxmlformats.org/officeDocument/2006/relationships" xmlns:a="http://schemas.openxmlformats.org/drawingml/2006/main" r:embed="R06b93f04cc0d4ac3"/>
           <a:stretch xmlns:a="http://schemas.openxmlformats.org/drawingml/2006/main"/>
         </p:blipFill>
         <p:spPr>
@@ -6331,7 +6341,7 @@
           <p:cNvPr id="4" name="">
             <a:extLst xmlns:a="http://schemas.openxmlformats.org/drawingml/2006/main">
               <a:ext uri="{FF2B5EF4-FFF2-40B4-BE49-F238E27FC236}">
-                <a16:creationId xmlns:a16="http://schemas.microsoft.com/office/drawing/2014/main" id="{541E53B2-E091-4ECE-A5FC-73F854C46DE2}"/>
+                <a16:creationId xmlns:a16="http://schemas.microsoft.com/office/drawing/2014/main" id="{61077DCB-F184-4626-8509-FC2966BC6473}"/>
               </a:ext>
             </a:extLst>
           </p:cNvPr>
@@ -6517,7 +6527,7 @@
           <p:cNvPr id="5" name="">
             <a:extLst xmlns:a="http://schemas.openxmlformats.org/drawingml/2006/main">
               <a:ext uri="{FF2B5EF4-FFF2-40B4-BE49-F238E27FC236}">
-                <a16:creationId xmlns:a16="http://schemas.microsoft.com/office/drawing/2014/main" id="{5149C002-02F8-4F27-BE77-FE0B7796DFB6}"/>
+                <a16:creationId xmlns:a16="http://schemas.microsoft.com/office/drawing/2014/main" id="{9477E2DC-23BB-4749-9615-88457DE167C4}"/>
               </a:ext>
             </a:extLst>
           </p:cNvPr>
@@ -6675,7 +6685,7 @@
           <p:cNvPr id="6" name="">
             <a:extLst xmlns:a="http://schemas.openxmlformats.org/drawingml/2006/main">
               <a:ext uri="{FF2B5EF4-FFF2-40B4-BE49-F238E27FC236}">
-                <a16:creationId xmlns:a16="http://schemas.microsoft.com/office/drawing/2014/main" id="{88DC9E22-7688-46B7-9677-690C6BD9CEFE}"/>
+                <a16:creationId xmlns:a16="http://schemas.microsoft.com/office/drawing/2014/main" id="{D7DE0A21-05A5-4F26-BD16-DA8F6A8C98E7}"/>
               </a:ext>
             </a:extLst>
           </p:cNvPr>
@@ -6831,7 +6841,7 @@
     </p:spTree>
     <p:extLst>
       <p:ext uri="{BB962C8B-B14F-4D97-AF65-F5344CB8AC3E}">
-        <p14:creationId xmlns:p14="http://schemas.microsoft.com/office/powerpoint/2010/main" val="1723721369"/>
+        <p14:creationId xmlns:p14="http://schemas.microsoft.com/office/powerpoint/2010/main" val="2083991875"/>
       </p:ext>
     </p:extLst>
   </p:cSld>
@@ -6862,7 +6872,7 @@
           <p:cNvPr id="6" name="">
             <a:extLst xmlns:a="http://schemas.openxmlformats.org/drawingml/2006/main">
               <a:ext uri="{FF2B5EF4-FFF2-40B4-BE49-F238E27FC236}">
-                <a16:creationId xmlns:a16="http://schemas.microsoft.com/office/drawing/2014/main" id="{31934790-176A-47D0-BFC1-7E01CDAC56E6}"/>
+                <a16:creationId xmlns:a16="http://schemas.microsoft.com/office/drawing/2014/main" id="{C8F30851-F05D-4281-B603-C62D425019B1}"/>
               </a:ext>
             </a:extLst>
           </p:cNvPr>
@@ -7020,7 +7030,7 @@
           <p:cNvPr id="2" name="">
             <a:extLst xmlns:a="http://schemas.openxmlformats.org/drawingml/2006/main">
               <a:ext uri="{FF2B5EF4-FFF2-40B4-BE49-F238E27FC236}">
-                <a16:creationId xmlns:a16="http://schemas.microsoft.com/office/drawing/2014/main" id="{77D24E24-01EB-484D-92C8-A51719F39B12}"/>
+                <a16:creationId xmlns:a16="http://schemas.microsoft.com/office/drawing/2014/main" id="{046ACA0B-E594-4347-9B34-0A52F7DA8FBD}"/>
               </a:ext>
             </a:extLst>
           </p:cNvPr>
@@ -7178,7 +7188,7 @@
           <p:cNvPr id="3" name="">
             <a:extLst xmlns:a="http://schemas.openxmlformats.org/drawingml/2006/main">
               <a:ext uri="{FF2B5EF4-FFF2-40B4-BE49-F238E27FC236}">
-                <a16:creationId xmlns:a16="http://schemas.microsoft.com/office/drawing/2014/main" id="{84FE0D42-C4C3-4DEB-BEF4-862988ADC5EC}"/>
+                <a16:creationId xmlns:a16="http://schemas.microsoft.com/office/drawing/2014/main" id="{D36B4BC5-A210-429C-AD4A-72CA23F71DEC}"/>
               </a:ext>
             </a:extLst>
           </p:cNvPr>
@@ -7769,7 +7779,7 @@
           <p:cNvPr id="4" name="">
             <a:extLst xmlns:a="http://schemas.openxmlformats.org/drawingml/2006/main">
               <a:ext uri="{FF2B5EF4-FFF2-40B4-BE49-F238E27FC236}">
-                <a16:creationId xmlns:a16="http://schemas.microsoft.com/office/drawing/2014/main" id="{5205A510-AB4E-4336-A5D5-32CFFE553870}"/>
+                <a16:creationId xmlns:a16="http://schemas.microsoft.com/office/drawing/2014/main" id="{40E9BCFD-FE2A-4574-97CF-44DB1FBC8C3D}"/>
               </a:ext>
             </a:extLst>
           </p:cNvPr>
@@ -7950,7 +7960,7 @@
           <p:cNvPr id="5" name="">
             <a:extLst xmlns:a="http://schemas.openxmlformats.org/drawingml/2006/main">
               <a:ext uri="{FF2B5EF4-FFF2-40B4-BE49-F238E27FC236}">
-                <a16:creationId xmlns:a16="http://schemas.microsoft.com/office/drawing/2014/main" id="{09034870-98E8-4D26-A397-FA78B3D94FAB}"/>
+                <a16:creationId xmlns:a16="http://schemas.microsoft.com/office/drawing/2014/main" id="{916F71A4-69F6-4EBF-8B09-C3E85C1AC7BF}"/>
               </a:ext>
             </a:extLst>
           </p:cNvPr>
@@ -8106,7 +8116,7 @@
     </p:spTree>
     <p:extLst>
       <p:ext uri="{BB962C8B-B14F-4D97-AF65-F5344CB8AC3E}">
-        <p14:creationId xmlns:p14="http://schemas.microsoft.com/office/powerpoint/2010/main" val="795584609"/>
+        <p14:creationId xmlns:p14="http://schemas.microsoft.com/office/powerpoint/2010/main" val="302747313"/>
       </p:ext>
     </p:extLst>
   </p:cSld>
@@ -8137,7 +8147,7 @@
           <p:cNvPr id="7" name="">
             <a:extLst xmlns:a="http://schemas.openxmlformats.org/drawingml/2006/main">
               <a:ext uri="{FF2B5EF4-FFF2-40B4-BE49-F238E27FC236}">
-                <a16:creationId xmlns:a16="http://schemas.microsoft.com/office/drawing/2014/main" id="{E2E26FA2-B56E-43F6-B3A1-F0B8A65BCED0}"/>
+                <a16:creationId xmlns:a16="http://schemas.microsoft.com/office/drawing/2014/main" id="{D841140C-912F-4D91-AB95-419788C2F84F}"/>
               </a:ext>
             </a:extLst>
           </p:cNvPr>
@@ -8295,7 +8305,7 @@
           <p:cNvPr id="2" name="">
             <a:extLst xmlns:a="http://schemas.openxmlformats.org/drawingml/2006/main">
               <a:ext uri="{FF2B5EF4-FFF2-40B4-BE49-F238E27FC236}">
-                <a16:creationId xmlns:a16="http://schemas.microsoft.com/office/drawing/2014/main" id="{D67A2625-531D-4450-ACE5-EB34AC02F764}"/>
+                <a16:creationId xmlns:a16="http://schemas.microsoft.com/office/drawing/2014/main" id="{3F0D9CD6-24EF-4E62-8840-AFC83C638628}"/>
               </a:ext>
             </a:extLst>
           </p:cNvPr>
@@ -8453,7 +8463,7 @@
           <p:cNvPr id="3" name="">
             <a:extLst xmlns:a="http://schemas.openxmlformats.org/drawingml/2006/main">
               <a:ext uri="{FF2B5EF4-FFF2-40B4-BE49-F238E27FC236}">
-                <a16:creationId xmlns:a16="http://schemas.microsoft.com/office/drawing/2014/main" id="{4A111306-49F1-4742-9220-ED4B28AF0FB8}"/>
+                <a16:creationId xmlns:a16="http://schemas.microsoft.com/office/drawing/2014/main" id="{3A55DCE7-06A7-4BC7-A3AB-97F8618D87C5}"/>
               </a:ext>
             </a:extLst>
           </p:cNvPr>
@@ -8463,7 +8473,7 @@
           <p:nvPr/>
         </p:nvPicPr>
         <p:blipFill>
-          <a:blip xmlns:r="http://schemas.openxmlformats.org/officeDocument/2006/relationships" xmlns:a="http://schemas.openxmlformats.org/drawingml/2006/main" r:embed="Rf8fd2953693b4c83"/>
+          <a:blip xmlns:r="http://schemas.openxmlformats.org/officeDocument/2006/relationships" xmlns:a="http://schemas.openxmlformats.org/drawingml/2006/main" r:embed="R765db50bc16f4c42"/>
           <a:stretch xmlns:a="http://schemas.openxmlformats.org/drawingml/2006/main"/>
         </p:blipFill>
         <p:spPr>
@@ -8481,7 +8491,7 @@
           <p:cNvPr id="4" name="">
             <a:extLst xmlns:a="http://schemas.openxmlformats.org/drawingml/2006/main">
               <a:ext uri="{FF2B5EF4-FFF2-40B4-BE49-F238E27FC236}">
-                <a16:creationId xmlns:a16="http://schemas.microsoft.com/office/drawing/2014/main" id="{92DC0E7E-8348-4DBD-8523-508C71DDB841}"/>
+                <a16:creationId xmlns:a16="http://schemas.microsoft.com/office/drawing/2014/main" id="{2E667E8E-8037-4947-808D-A02DD91F582C}"/>
               </a:ext>
             </a:extLst>
           </p:cNvPr>
@@ -8667,7 +8677,7 @@
           <p:cNvPr id="5" name="">
             <a:extLst xmlns:a="http://schemas.openxmlformats.org/drawingml/2006/main">
               <a:ext uri="{FF2B5EF4-FFF2-40B4-BE49-F238E27FC236}">
-                <a16:creationId xmlns:a16="http://schemas.microsoft.com/office/drawing/2014/main" id="{D2B32CB0-0FB9-4838-8B5C-50E991CA70A4}"/>
+                <a16:creationId xmlns:a16="http://schemas.microsoft.com/office/drawing/2014/main" id="{825CB6E1-1630-4343-B447-83CC67C49EF3}"/>
               </a:ext>
             </a:extLst>
           </p:cNvPr>
@@ -8825,7 +8835,7 @@
           <p:cNvPr id="6" name="">
             <a:extLst xmlns:a="http://schemas.openxmlformats.org/drawingml/2006/main">
               <a:ext uri="{FF2B5EF4-FFF2-40B4-BE49-F238E27FC236}">
-                <a16:creationId xmlns:a16="http://schemas.microsoft.com/office/drawing/2014/main" id="{0C67ECF9-C966-4AFA-AB31-30056BF7C020}"/>
+                <a16:creationId xmlns:a16="http://schemas.microsoft.com/office/drawing/2014/main" id="{16813967-6CCA-41AA-91E9-3CDF13614DA7}"/>
               </a:ext>
             </a:extLst>
           </p:cNvPr>
@@ -8981,7 +8991,7 @@
     </p:spTree>
     <p:extLst>
       <p:ext uri="{BB962C8B-B14F-4D97-AF65-F5344CB8AC3E}">
-        <p14:creationId xmlns:p14="http://schemas.microsoft.com/office/powerpoint/2010/main" val="207147403"/>
+        <p14:creationId xmlns:p14="http://schemas.microsoft.com/office/powerpoint/2010/main" val="1568313189"/>
       </p:ext>
     </p:extLst>
   </p:cSld>
@@ -9012,7 +9022,7 @@
           <p:cNvPr id="6" name="">
             <a:extLst xmlns:a="http://schemas.openxmlformats.org/drawingml/2006/main">
               <a:ext uri="{FF2B5EF4-FFF2-40B4-BE49-F238E27FC236}">
-                <a16:creationId xmlns:a16="http://schemas.microsoft.com/office/drawing/2014/main" id="{59E895AF-51C2-4427-9867-10557E1C91AB}"/>
+                <a16:creationId xmlns:a16="http://schemas.microsoft.com/office/drawing/2014/main" id="{E787F01B-C43D-490C-A619-58C5D71BDF0D}"/>
               </a:ext>
             </a:extLst>
           </p:cNvPr>
@@ -9170,7 +9180,7 @@
           <p:cNvPr id="2" name="">
             <a:extLst xmlns:a="http://schemas.openxmlformats.org/drawingml/2006/main">
               <a:ext uri="{FF2B5EF4-FFF2-40B4-BE49-F238E27FC236}">
-                <a16:creationId xmlns:a16="http://schemas.microsoft.com/office/drawing/2014/main" id="{BDFA050A-E9B9-4921-BB14-25FBFFF6B2A4}"/>
+                <a16:creationId xmlns:a16="http://schemas.microsoft.com/office/drawing/2014/main" id="{D206917C-F359-4450-8206-56FD5D2E38E5}"/>
               </a:ext>
             </a:extLst>
           </p:cNvPr>
@@ -9328,7 +9338,7 @@
           <p:cNvPr id="3" name="">
             <a:extLst xmlns:a="http://schemas.openxmlformats.org/drawingml/2006/main">
               <a:ext uri="{FF2B5EF4-FFF2-40B4-BE49-F238E27FC236}">
-                <a16:creationId xmlns:a16="http://schemas.microsoft.com/office/drawing/2014/main" id="{2DF9A75E-CA0F-474C-AB93-C40314B81E6F}"/>
+                <a16:creationId xmlns:a16="http://schemas.microsoft.com/office/drawing/2014/main" id="{9115261E-6B36-48EA-8B66-33795CB1DC6B}"/>
               </a:ext>
             </a:extLst>
           </p:cNvPr>
@@ -10094,7 +10104,7 @@
           <p:cNvPr id="4" name="">
             <a:extLst xmlns:a="http://schemas.openxmlformats.org/drawingml/2006/main">
               <a:ext uri="{FF2B5EF4-FFF2-40B4-BE49-F238E27FC236}">
-                <a16:creationId xmlns:a16="http://schemas.microsoft.com/office/drawing/2014/main" id="{874BE988-1E1D-4987-8514-99575C717F08}"/>
+                <a16:creationId xmlns:a16="http://schemas.microsoft.com/office/drawing/2014/main" id="{BF4F5D3B-40D7-49FA-A954-2605907A29AB}"/>
               </a:ext>
             </a:extLst>
           </p:cNvPr>
@@ -10275,7 +10285,7 @@
           <p:cNvPr id="5" name="">
             <a:extLst xmlns:a="http://schemas.openxmlformats.org/drawingml/2006/main">
               <a:ext uri="{FF2B5EF4-FFF2-40B4-BE49-F238E27FC236}">
-                <a16:creationId xmlns:a16="http://schemas.microsoft.com/office/drawing/2014/main" id="{EEBA1CD0-6E0E-4207-A9B2-AA9FDD064974}"/>
+                <a16:creationId xmlns:a16="http://schemas.microsoft.com/office/drawing/2014/main" id="{55CE232A-BAF4-4140-9876-5391340D02BA}"/>
               </a:ext>
             </a:extLst>
           </p:cNvPr>
@@ -10431,7 +10441,7 @@
     </p:spTree>
     <p:extLst>
       <p:ext uri="{BB962C8B-B14F-4D97-AF65-F5344CB8AC3E}">
-        <p14:creationId xmlns:p14="http://schemas.microsoft.com/office/powerpoint/2010/main" val="567227909"/>
+        <p14:creationId xmlns:p14="http://schemas.microsoft.com/office/powerpoint/2010/main" val="1289750534"/>
       </p:ext>
     </p:extLst>
   </p:cSld>
@@ -10462,7 +10472,7 @@
           <p:cNvPr id="7" name="">
             <a:extLst xmlns:a="http://schemas.openxmlformats.org/drawingml/2006/main">
               <a:ext uri="{FF2B5EF4-FFF2-40B4-BE49-F238E27FC236}">
-                <a16:creationId xmlns:a16="http://schemas.microsoft.com/office/drawing/2014/main" id="{B356D6C7-154F-45D6-9577-1CCCB9292FD3}"/>
+                <a16:creationId xmlns:a16="http://schemas.microsoft.com/office/drawing/2014/main" id="{EAA441D3-4331-41EE-9673-FD9DFC581000}"/>
               </a:ext>
             </a:extLst>
           </p:cNvPr>
@@ -10620,7 +10630,7 @@
           <p:cNvPr id="2" name="">
             <a:extLst xmlns:a="http://schemas.openxmlformats.org/drawingml/2006/main">
               <a:ext uri="{FF2B5EF4-FFF2-40B4-BE49-F238E27FC236}">
-                <a16:creationId xmlns:a16="http://schemas.microsoft.com/office/drawing/2014/main" id="{315E03E1-709D-4B98-ABEE-B3B14AFA855C}"/>
+                <a16:creationId xmlns:a16="http://schemas.microsoft.com/office/drawing/2014/main" id="{BB46363E-6735-4447-B167-FAF1811B73DF}"/>
               </a:ext>
             </a:extLst>
           </p:cNvPr>
@@ -10778,7 +10788,7 @@
           <p:cNvPr id="3" name="">
             <a:extLst xmlns:a="http://schemas.openxmlformats.org/drawingml/2006/main">
               <a:ext uri="{FF2B5EF4-FFF2-40B4-BE49-F238E27FC236}">
-                <a16:creationId xmlns:a16="http://schemas.microsoft.com/office/drawing/2014/main" id="{E32A177D-C204-4E9F-ADB4-BE7A03D8DF63}"/>
+                <a16:creationId xmlns:a16="http://schemas.microsoft.com/office/drawing/2014/main" id="{5E656201-FD48-4C3D-A93A-9A1DD16E293F}"/>
               </a:ext>
             </a:extLst>
           </p:cNvPr>
@@ -10788,7 +10798,7 @@
           <p:nvPr/>
         </p:nvPicPr>
         <p:blipFill>
-          <a:blip xmlns:r="http://schemas.openxmlformats.org/officeDocument/2006/relationships" xmlns:a="http://schemas.openxmlformats.org/drawingml/2006/main" r:embed="R6e6fb66cf9c84e09"/>
+          <a:blip xmlns:r="http://schemas.openxmlformats.org/officeDocument/2006/relationships" xmlns:a="http://schemas.openxmlformats.org/drawingml/2006/main" r:embed="Rd3b01af5606d4d82"/>
           <a:stretch xmlns:a="http://schemas.openxmlformats.org/drawingml/2006/main"/>
         </p:blipFill>
         <p:spPr>
@@ -10806,7 +10816,7 @@
           <p:cNvPr id="4" name="">
             <a:extLst xmlns:a="http://schemas.openxmlformats.org/drawingml/2006/main">
               <a:ext uri="{FF2B5EF4-FFF2-40B4-BE49-F238E27FC236}">
-                <a16:creationId xmlns:a16="http://schemas.microsoft.com/office/drawing/2014/main" id="{6D88F839-153A-470B-9338-FE5466D8EF40}"/>
+                <a16:creationId xmlns:a16="http://schemas.microsoft.com/office/drawing/2014/main" id="{827A9CB3-C7C6-4458-B14A-557CE2AE0015}"/>
               </a:ext>
             </a:extLst>
           </p:cNvPr>
@@ -10992,7 +11002,7 @@
           <p:cNvPr id="5" name="">
             <a:extLst xmlns:a="http://schemas.openxmlformats.org/drawingml/2006/main">
               <a:ext uri="{FF2B5EF4-FFF2-40B4-BE49-F238E27FC236}">
-                <a16:creationId xmlns:a16="http://schemas.microsoft.com/office/drawing/2014/main" id="{90238F0F-D07F-4D11-8238-EEF9403CC191}"/>
+                <a16:creationId xmlns:a16="http://schemas.microsoft.com/office/drawing/2014/main" id="{5D2C8676-CD60-46E4-97AA-6E5A8F73C9AB}"/>
               </a:ext>
             </a:extLst>
           </p:cNvPr>
@@ -11150,7 +11160,7 @@
           <p:cNvPr id="6" name="">
             <a:extLst xmlns:a="http://schemas.openxmlformats.org/drawingml/2006/main">
               <a:ext uri="{FF2B5EF4-FFF2-40B4-BE49-F238E27FC236}">
-                <a16:creationId xmlns:a16="http://schemas.microsoft.com/office/drawing/2014/main" id="{45BF1F12-F2E2-4FBE-BC5C-25502673D705}"/>
+                <a16:creationId xmlns:a16="http://schemas.microsoft.com/office/drawing/2014/main" id="{7B36AD65-D31F-42F5-834A-FF7D43114327}"/>
               </a:ext>
             </a:extLst>
           </p:cNvPr>
@@ -11306,7 +11316,7 @@
     </p:spTree>
     <p:extLst>
       <p:ext uri="{BB962C8B-B14F-4D97-AF65-F5344CB8AC3E}">
-        <p14:creationId xmlns:p14="http://schemas.microsoft.com/office/powerpoint/2010/main" val="877691187"/>
+        <p14:creationId xmlns:p14="http://schemas.microsoft.com/office/powerpoint/2010/main" val="1333479613"/>
       </p:ext>
     </p:extLst>
   </p:cSld>
@@ -11337,7 +11347,7 @@
           <p:cNvPr id="7" name="">
             <a:extLst xmlns:a="http://schemas.openxmlformats.org/drawingml/2006/main">
               <a:ext uri="{FF2B5EF4-FFF2-40B4-BE49-F238E27FC236}">
-                <a16:creationId xmlns:a16="http://schemas.microsoft.com/office/drawing/2014/main" id="{588772BC-4932-4F77-B5DE-0DDC8856E866}"/>
+                <a16:creationId xmlns:a16="http://schemas.microsoft.com/office/drawing/2014/main" id="{3FBF97DA-2DD6-46F4-9043-6198B539F655}"/>
               </a:ext>
             </a:extLst>
           </p:cNvPr>
@@ -11495,7 +11505,7 @@
           <p:cNvPr id="2" name="">
             <a:extLst xmlns:a="http://schemas.openxmlformats.org/drawingml/2006/main">
               <a:ext uri="{FF2B5EF4-FFF2-40B4-BE49-F238E27FC236}">
-                <a16:creationId xmlns:a16="http://schemas.microsoft.com/office/drawing/2014/main" id="{CB3F93BC-6B6D-4581-9C67-3C80F3AE1021}"/>
+                <a16:creationId xmlns:a16="http://schemas.microsoft.com/office/drawing/2014/main" id="{49E6CA45-7450-4EB4-BF30-690F7F3924EC}"/>
               </a:ext>
             </a:extLst>
           </p:cNvPr>
@@ -11653,7 +11663,7 @@
           <p:cNvPr id="3" name="">
             <a:extLst xmlns:a="http://schemas.openxmlformats.org/drawingml/2006/main">
               <a:ext uri="{FF2B5EF4-FFF2-40B4-BE49-F238E27FC236}">
-                <a16:creationId xmlns:a16="http://schemas.microsoft.com/office/drawing/2014/main" id="{AE7F3DAD-26C6-4486-A608-1C2BFA4E4EB5}"/>
+                <a16:creationId xmlns:a16="http://schemas.microsoft.com/office/drawing/2014/main" id="{80D41190-7A6F-43C5-A853-D143C85049D1}"/>
               </a:ext>
             </a:extLst>
           </p:cNvPr>
@@ -11663,7 +11673,7 @@
           <p:nvPr/>
         </p:nvPicPr>
         <p:blipFill>
-          <a:blip xmlns:r="http://schemas.openxmlformats.org/officeDocument/2006/relationships" xmlns:a="http://schemas.openxmlformats.org/drawingml/2006/main" r:embed="R24d402911e49433f"/>
+          <a:blip xmlns:r="http://schemas.openxmlformats.org/officeDocument/2006/relationships" xmlns:a="http://schemas.openxmlformats.org/drawingml/2006/main" r:embed="R24f8b540076742dc"/>
           <a:stretch xmlns:a="http://schemas.openxmlformats.org/drawingml/2006/main"/>
         </p:blipFill>
         <p:spPr>
@@ -11681,7 +11691,7 @@
           <p:cNvPr id="4" name="">
             <a:extLst xmlns:a="http://schemas.openxmlformats.org/drawingml/2006/main">
               <a:ext uri="{FF2B5EF4-FFF2-40B4-BE49-F238E27FC236}">
-                <a16:creationId xmlns:a16="http://schemas.microsoft.com/office/drawing/2014/main" id="{A3B8F574-251D-4DC9-9E51-23139D772910}"/>
+                <a16:creationId xmlns:a16="http://schemas.microsoft.com/office/drawing/2014/main" id="{641F0196-A09C-4E0B-A564-A2D233FE4D83}"/>
               </a:ext>
             </a:extLst>
           </p:cNvPr>
@@ -11895,7 +11905,7 @@
           <p:cNvPr id="5" name="">
             <a:extLst xmlns:a="http://schemas.openxmlformats.org/drawingml/2006/main">
               <a:ext uri="{FF2B5EF4-FFF2-40B4-BE49-F238E27FC236}">
-                <a16:creationId xmlns:a16="http://schemas.microsoft.com/office/drawing/2014/main" id="{387B8088-607F-4D89-B4A7-C4E8439EB613}"/>
+                <a16:creationId xmlns:a16="http://schemas.microsoft.com/office/drawing/2014/main" id="{7D0CB966-928F-4D38-8333-426052979BE0}"/>
               </a:ext>
             </a:extLst>
           </p:cNvPr>
@@ -12053,7 +12063,7 @@
           <p:cNvPr id="6" name="">
             <a:extLst xmlns:a="http://schemas.openxmlformats.org/drawingml/2006/main">
               <a:ext uri="{FF2B5EF4-FFF2-40B4-BE49-F238E27FC236}">
-                <a16:creationId xmlns:a16="http://schemas.microsoft.com/office/drawing/2014/main" id="{AC35A163-84C1-4295-A070-1B44B00EB32F}"/>
+                <a16:creationId xmlns:a16="http://schemas.microsoft.com/office/drawing/2014/main" id="{C5C64526-499C-472B-9C60-3DDD4FDC7705}"/>
               </a:ext>
             </a:extLst>
           </p:cNvPr>
@@ -12209,7 +12219,7 @@
     </p:spTree>
     <p:extLst>
       <p:ext uri="{BB962C8B-B14F-4D97-AF65-F5344CB8AC3E}">
-        <p14:creationId xmlns:p14="http://schemas.microsoft.com/office/powerpoint/2010/main" val="1866333940"/>
+        <p14:creationId xmlns:p14="http://schemas.microsoft.com/office/powerpoint/2010/main" val="388200489"/>
       </p:ext>
     </p:extLst>
   </p:cSld>
@@ -12240,7 +12250,7 @@
           <p:cNvPr id="7" name="">
             <a:extLst xmlns:a="http://schemas.openxmlformats.org/drawingml/2006/main">
               <a:ext uri="{FF2B5EF4-FFF2-40B4-BE49-F238E27FC236}">
-                <a16:creationId xmlns:a16="http://schemas.microsoft.com/office/drawing/2014/main" id="{38E8D2E4-6790-473A-9650-34E9ACC16BF8}"/>
+                <a16:creationId xmlns:a16="http://schemas.microsoft.com/office/drawing/2014/main" id="{28F15929-D058-4F75-BAE2-3C2E248DFE39}"/>
               </a:ext>
             </a:extLst>
           </p:cNvPr>
@@ -12398,7 +12408,7 @@
           <p:cNvPr id="2" name="">
             <a:extLst xmlns:a="http://schemas.openxmlformats.org/drawingml/2006/main">
               <a:ext uri="{FF2B5EF4-FFF2-40B4-BE49-F238E27FC236}">
-                <a16:creationId xmlns:a16="http://schemas.microsoft.com/office/drawing/2014/main" id="{C0ABF7C9-D41C-4623-BCEC-1D7FF667A53B}"/>
+                <a16:creationId xmlns:a16="http://schemas.microsoft.com/office/drawing/2014/main" id="{B3F67377-2A3E-44FC-B1F7-B01FFD65F092}"/>
               </a:ext>
             </a:extLst>
           </p:cNvPr>
@@ -12556,7 +12566,7 @@
           <p:cNvPr id="3" name="">
             <a:extLst xmlns:a="http://schemas.openxmlformats.org/drawingml/2006/main">
               <a:ext uri="{FF2B5EF4-FFF2-40B4-BE49-F238E27FC236}">
-                <a16:creationId xmlns:a16="http://schemas.microsoft.com/office/drawing/2014/main" id="{68852DF8-45A7-47D4-A71F-B4A042CB65BE}"/>
+                <a16:creationId xmlns:a16="http://schemas.microsoft.com/office/drawing/2014/main" id="{B8AB935A-BD9D-4FD9-A717-E91E5477F67F}"/>
               </a:ext>
             </a:extLst>
           </p:cNvPr>
@@ -12566,7 +12576,7 @@
           <p:nvPr/>
         </p:nvPicPr>
         <p:blipFill>
-          <a:blip xmlns:r="http://schemas.openxmlformats.org/officeDocument/2006/relationships" xmlns:a="http://schemas.openxmlformats.org/drawingml/2006/main" r:embed="R9e2ad6fd887b4490"/>
+          <a:blip xmlns:r="http://schemas.openxmlformats.org/officeDocument/2006/relationships" xmlns:a="http://schemas.openxmlformats.org/drawingml/2006/main" r:embed="R873a77b68bfe4145"/>
           <a:stretch xmlns:a="http://schemas.openxmlformats.org/drawingml/2006/main"/>
         </p:blipFill>
         <p:spPr>
@@ -12584,7 +12594,7 @@
           <p:cNvPr id="4" name="">
             <a:extLst xmlns:a="http://schemas.openxmlformats.org/drawingml/2006/main">
               <a:ext uri="{FF2B5EF4-FFF2-40B4-BE49-F238E27FC236}">
-                <a16:creationId xmlns:a16="http://schemas.microsoft.com/office/drawing/2014/main" id="{87E737D0-68BF-4DDE-8E95-36C4871B4B2A}"/>
+                <a16:creationId xmlns:a16="http://schemas.microsoft.com/office/drawing/2014/main" id="{78C8565B-4271-486E-9F29-6209461812FE}"/>
               </a:ext>
             </a:extLst>
           </p:cNvPr>
@@ -12770,7 +12780,7 @@
           <p:cNvPr id="5" name="">
             <a:extLst xmlns:a="http://schemas.openxmlformats.org/drawingml/2006/main">
               <a:ext uri="{FF2B5EF4-FFF2-40B4-BE49-F238E27FC236}">
-                <a16:creationId xmlns:a16="http://schemas.microsoft.com/office/drawing/2014/main" id="{618A4C32-3825-4BFB-96BD-1A1746B30A2D}"/>
+                <a16:creationId xmlns:a16="http://schemas.microsoft.com/office/drawing/2014/main" id="{7C589719-300E-4470-82FD-53EB7714BD0F}"/>
               </a:ext>
             </a:extLst>
           </p:cNvPr>
@@ -12928,7 +12938,7 @@
           <p:cNvPr id="6" name="">
             <a:extLst xmlns:a="http://schemas.openxmlformats.org/drawingml/2006/main">
               <a:ext uri="{FF2B5EF4-FFF2-40B4-BE49-F238E27FC236}">
-                <a16:creationId xmlns:a16="http://schemas.microsoft.com/office/drawing/2014/main" id="{611F485E-B456-4E4E-8ACF-00B1385805DC}"/>
+                <a16:creationId xmlns:a16="http://schemas.microsoft.com/office/drawing/2014/main" id="{B94831F5-A917-41DD-A822-442882EB95AE}"/>
               </a:ext>
             </a:extLst>
           </p:cNvPr>
@@ -13084,7 +13094,7 @@
     </p:spTree>
     <p:extLst>
       <p:ext uri="{BB962C8B-B14F-4D97-AF65-F5344CB8AC3E}">
-        <p14:creationId xmlns:p14="http://schemas.microsoft.com/office/powerpoint/2010/main" val="1972352113"/>
+        <p14:creationId xmlns:p14="http://schemas.microsoft.com/office/powerpoint/2010/main" val="141488590"/>
       </p:ext>
     </p:extLst>
   </p:cSld>
@@ -13115,7 +13125,7 @@
           <p:cNvPr id="6" name="">
             <a:extLst xmlns:a="http://schemas.openxmlformats.org/drawingml/2006/main">
               <a:ext uri="{FF2B5EF4-FFF2-40B4-BE49-F238E27FC236}">
-                <a16:creationId xmlns:a16="http://schemas.microsoft.com/office/drawing/2014/main" id="{190E55DF-3BD2-4DDE-80C7-F63A75597666}"/>
+                <a16:creationId xmlns:a16="http://schemas.microsoft.com/office/drawing/2014/main" id="{1584433A-045A-44B3-ACEC-AE1BFBF19637}"/>
               </a:ext>
             </a:extLst>
           </p:cNvPr>
@@ -13273,7 +13283,7 @@
           <p:cNvPr id="2" name="">
             <a:extLst xmlns:a="http://schemas.openxmlformats.org/drawingml/2006/main">
               <a:ext uri="{FF2B5EF4-FFF2-40B4-BE49-F238E27FC236}">
-                <a16:creationId xmlns:a16="http://schemas.microsoft.com/office/drawing/2014/main" id="{31FE2A14-6F5A-4895-99FE-F58193015DB4}"/>
+                <a16:creationId xmlns:a16="http://schemas.microsoft.com/office/drawing/2014/main" id="{81554EA5-3DBE-4372-A5A7-557FE36448D7}"/>
               </a:ext>
             </a:extLst>
           </p:cNvPr>
@@ -13431,7 +13441,7 @@
           <p:cNvPr id="3" name="">
             <a:extLst xmlns:a="http://schemas.openxmlformats.org/drawingml/2006/main">
               <a:ext uri="{FF2B5EF4-FFF2-40B4-BE49-F238E27FC236}">
-                <a16:creationId xmlns:a16="http://schemas.microsoft.com/office/drawing/2014/main" id="{022EB03E-392F-4ED2-B4A1-30CBE8A0B186}"/>
+                <a16:creationId xmlns:a16="http://schemas.microsoft.com/office/drawing/2014/main" id="{1BF56844-FD2C-4E5D-A2CC-29F7FCAA0D6F}"/>
               </a:ext>
             </a:extLst>
           </p:cNvPr>
@@ -14057,7 +14067,7 @@
           <p:cNvPr id="4" name="">
             <a:extLst xmlns:a="http://schemas.openxmlformats.org/drawingml/2006/main">
               <a:ext uri="{FF2B5EF4-FFF2-40B4-BE49-F238E27FC236}">
-                <a16:creationId xmlns:a16="http://schemas.microsoft.com/office/drawing/2014/main" id="{3179F8EF-1D42-47C9-92BC-6E8E458F7A63}"/>
+                <a16:creationId xmlns:a16="http://schemas.microsoft.com/office/drawing/2014/main" id="{1C423F0C-4805-42D6-8156-C8CF9767A449}"/>
               </a:ext>
             </a:extLst>
           </p:cNvPr>
@@ -14238,7 +14248,7 @@
           <p:cNvPr id="5" name="">
             <a:extLst xmlns:a="http://schemas.openxmlformats.org/drawingml/2006/main">
               <a:ext uri="{FF2B5EF4-FFF2-40B4-BE49-F238E27FC236}">
-                <a16:creationId xmlns:a16="http://schemas.microsoft.com/office/drawing/2014/main" id="{9529BB54-E95D-40E6-9804-90B5B709D95E}"/>
+                <a16:creationId xmlns:a16="http://schemas.microsoft.com/office/drawing/2014/main" id="{CD47E0B7-8BF7-4CDB-A4F6-DD8801E9BE9D}"/>
               </a:ext>
             </a:extLst>
           </p:cNvPr>
@@ -14394,7 +14404,7 @@
     </p:spTree>
     <p:extLst>
       <p:ext uri="{BB962C8B-B14F-4D97-AF65-F5344CB8AC3E}">
-        <p14:creationId xmlns:p14="http://schemas.microsoft.com/office/powerpoint/2010/main" val="1658811614"/>
+        <p14:creationId xmlns:p14="http://schemas.microsoft.com/office/powerpoint/2010/main" val="107755226"/>
       </p:ext>
     </p:extLst>
   </p:cSld>
@@ -14425,7 +14435,7 @@
           <p:cNvPr id="7" name="">
             <a:extLst xmlns:a="http://schemas.openxmlformats.org/drawingml/2006/main">
               <a:ext uri="{FF2B5EF4-FFF2-40B4-BE49-F238E27FC236}">
-                <a16:creationId xmlns:a16="http://schemas.microsoft.com/office/drawing/2014/main" id="{26C2FB15-2A35-4CBB-9398-7A6E496EF51B}"/>
+                <a16:creationId xmlns:a16="http://schemas.microsoft.com/office/drawing/2014/main" id="{22A40172-F01F-465A-AEF5-253AF85255BC}"/>
               </a:ext>
             </a:extLst>
           </p:cNvPr>
@@ -14583,7 +14593,7 @@
           <p:cNvPr id="2" name="">
             <a:extLst xmlns:a="http://schemas.openxmlformats.org/drawingml/2006/main">
               <a:ext uri="{FF2B5EF4-FFF2-40B4-BE49-F238E27FC236}">
-                <a16:creationId xmlns:a16="http://schemas.microsoft.com/office/drawing/2014/main" id="{FA3C4977-B6B8-43A3-ABA5-4F4CE0C27594}"/>
+                <a16:creationId xmlns:a16="http://schemas.microsoft.com/office/drawing/2014/main" id="{2BDABF69-51F0-4611-9633-337674F610C6}"/>
               </a:ext>
             </a:extLst>
           </p:cNvPr>
@@ -14741,7 +14751,7 @@
           <p:cNvPr id="3" name="">
             <a:extLst xmlns:a="http://schemas.openxmlformats.org/drawingml/2006/main">
               <a:ext uri="{FF2B5EF4-FFF2-40B4-BE49-F238E27FC236}">
-                <a16:creationId xmlns:a16="http://schemas.microsoft.com/office/drawing/2014/main" id="{F75BF553-95DB-4C9E-9815-F6081C753E52}"/>
+                <a16:creationId xmlns:a16="http://schemas.microsoft.com/office/drawing/2014/main" id="{9CDB1AD7-0056-4F6F-91A3-EA993CB5B83D}"/>
               </a:ext>
             </a:extLst>
           </p:cNvPr>
@@ -14751,7 +14761,7 @@
           <p:nvPr/>
         </p:nvPicPr>
         <p:blipFill>
-          <a:blip xmlns:r="http://schemas.openxmlformats.org/officeDocument/2006/relationships" xmlns:a="http://schemas.openxmlformats.org/drawingml/2006/main" r:embed="Rd84ac67238df421a"/>
+          <a:blip xmlns:r="http://schemas.openxmlformats.org/officeDocument/2006/relationships" xmlns:a="http://schemas.openxmlformats.org/drawingml/2006/main" r:embed="Racb585ce66c84def"/>
           <a:stretch xmlns:a="http://schemas.openxmlformats.org/drawingml/2006/main"/>
         </p:blipFill>
         <p:spPr>
@@ -14769,7 +14779,7 @@
           <p:cNvPr id="4" name="">
             <a:extLst xmlns:a="http://schemas.openxmlformats.org/drawingml/2006/main">
               <a:ext uri="{FF2B5EF4-FFF2-40B4-BE49-F238E27FC236}">
-                <a16:creationId xmlns:a16="http://schemas.microsoft.com/office/drawing/2014/main" id="{9378D3F4-1F1C-4C84-B2FD-DD223909ED54}"/>
+                <a16:creationId xmlns:a16="http://schemas.microsoft.com/office/drawing/2014/main" id="{6C944D80-E306-403A-A386-9B82EC8C6F5D}"/>
               </a:ext>
             </a:extLst>
           </p:cNvPr>
@@ -14955,7 +14965,7 @@
           <p:cNvPr id="5" name="">
             <a:extLst xmlns:a="http://schemas.openxmlformats.org/drawingml/2006/main">
               <a:ext uri="{FF2B5EF4-FFF2-40B4-BE49-F238E27FC236}">
-                <a16:creationId xmlns:a16="http://schemas.microsoft.com/office/drawing/2014/main" id="{F2E0903D-EC26-4588-A4F6-8365CC14A35C}"/>
+                <a16:creationId xmlns:a16="http://schemas.microsoft.com/office/drawing/2014/main" id="{3F331CF0-0A07-413D-AC9E-FDF6C825672B}"/>
               </a:ext>
             </a:extLst>
           </p:cNvPr>
@@ -15113,7 +15123,7 @@
           <p:cNvPr id="6" name="">
             <a:extLst xmlns:a="http://schemas.openxmlformats.org/drawingml/2006/main">
               <a:ext uri="{FF2B5EF4-FFF2-40B4-BE49-F238E27FC236}">
-                <a16:creationId xmlns:a16="http://schemas.microsoft.com/office/drawing/2014/main" id="{8B326ABB-8B94-4E87-BABB-DFEB9872AFB9}"/>
+                <a16:creationId xmlns:a16="http://schemas.microsoft.com/office/drawing/2014/main" id="{1E07FE69-C0D9-4273-A613-F32CEFA808B6}"/>
               </a:ext>
             </a:extLst>
           </p:cNvPr>
@@ -15269,7 +15279,7 @@
     </p:spTree>
     <p:extLst>
       <p:ext uri="{BB962C8B-B14F-4D97-AF65-F5344CB8AC3E}">
-        <p14:creationId xmlns:p14="http://schemas.microsoft.com/office/powerpoint/2010/main" val="1584279185"/>
+        <p14:creationId xmlns:p14="http://schemas.microsoft.com/office/powerpoint/2010/main" val="1643579871"/>
       </p:ext>
     </p:extLst>
   </p:cSld>
@@ -15300,7 +15310,7 @@
           <p:cNvPr id="7" name="">
             <a:extLst xmlns:a="http://schemas.openxmlformats.org/drawingml/2006/main">
               <a:ext uri="{FF2B5EF4-FFF2-40B4-BE49-F238E27FC236}">
-                <a16:creationId xmlns:a16="http://schemas.microsoft.com/office/drawing/2014/main" id="{7A06DC7C-BE7A-4A9E-8F8C-3CED8AD165C7}"/>
+                <a16:creationId xmlns:a16="http://schemas.microsoft.com/office/drawing/2014/main" id="{EFDCA130-21D0-465F-8C7D-3478AEC4A0FE}"/>
               </a:ext>
             </a:extLst>
           </p:cNvPr>
@@ -15458,7 +15468,7 @@
           <p:cNvPr id="2" name="">
             <a:extLst xmlns:a="http://schemas.openxmlformats.org/drawingml/2006/main">
               <a:ext uri="{FF2B5EF4-FFF2-40B4-BE49-F238E27FC236}">
-                <a16:creationId xmlns:a16="http://schemas.microsoft.com/office/drawing/2014/main" id="{6B8D9B4E-672C-43E9-AD33-47593BBE27DE}"/>
+                <a16:creationId xmlns:a16="http://schemas.microsoft.com/office/drawing/2014/main" id="{43CD94A3-7095-4C29-B3C9-46BA334BD94A}"/>
               </a:ext>
             </a:extLst>
           </p:cNvPr>
@@ -15616,7 +15626,7 @@
           <p:cNvPr id="3" name="">
             <a:extLst xmlns:a="http://schemas.openxmlformats.org/drawingml/2006/main">
               <a:ext uri="{FF2B5EF4-FFF2-40B4-BE49-F238E27FC236}">
-                <a16:creationId xmlns:a16="http://schemas.microsoft.com/office/drawing/2014/main" id="{CCF8F393-5B75-470A-B738-D4247276526A}"/>
+                <a16:creationId xmlns:a16="http://schemas.microsoft.com/office/drawing/2014/main" id="{42E83306-0FB7-4418-A7B1-52906989BB1C}"/>
               </a:ext>
             </a:extLst>
           </p:cNvPr>
@@ -15626,7 +15636,7 @@
           <p:nvPr/>
         </p:nvPicPr>
         <p:blipFill>
-          <a:blip xmlns:r="http://schemas.openxmlformats.org/officeDocument/2006/relationships" xmlns:a="http://schemas.openxmlformats.org/drawingml/2006/main" r:embed="Rd58a281fc165491f"/>
+          <a:blip xmlns:r="http://schemas.openxmlformats.org/officeDocument/2006/relationships" xmlns:a="http://schemas.openxmlformats.org/drawingml/2006/main" r:embed="R12732f62d63e40cc"/>
           <a:stretch xmlns:a="http://schemas.openxmlformats.org/drawingml/2006/main"/>
         </p:blipFill>
         <p:spPr>
@@ -15644,7 +15654,7 @@
           <p:cNvPr id="4" name="">
             <a:extLst xmlns:a="http://schemas.openxmlformats.org/drawingml/2006/main">
               <a:ext uri="{FF2B5EF4-FFF2-40B4-BE49-F238E27FC236}">
-                <a16:creationId xmlns:a16="http://schemas.microsoft.com/office/drawing/2014/main" id="{B86ADB4D-3DE9-4196-B400-6B1801A89A81}"/>
+                <a16:creationId xmlns:a16="http://schemas.microsoft.com/office/drawing/2014/main" id="{C26FF059-EAF1-421C-95DB-6D1FD5A81B0D}"/>
               </a:ext>
             </a:extLst>
           </p:cNvPr>
@@ -15830,7 +15840,7 @@
           <p:cNvPr id="5" name="">
             <a:extLst xmlns:a="http://schemas.openxmlformats.org/drawingml/2006/main">
               <a:ext uri="{FF2B5EF4-FFF2-40B4-BE49-F238E27FC236}">
-                <a16:creationId xmlns:a16="http://schemas.microsoft.com/office/drawing/2014/main" id="{92A34F2C-0291-4F5B-8090-520F85B0347F}"/>
+                <a16:creationId xmlns:a16="http://schemas.microsoft.com/office/drawing/2014/main" id="{6A3EC16A-7EEF-4E16-8F15-823CC2D38E2B}"/>
               </a:ext>
             </a:extLst>
           </p:cNvPr>
@@ -15988,7 +15998,7 @@
           <p:cNvPr id="6" name="">
             <a:extLst xmlns:a="http://schemas.openxmlformats.org/drawingml/2006/main">
               <a:ext uri="{FF2B5EF4-FFF2-40B4-BE49-F238E27FC236}">
-                <a16:creationId xmlns:a16="http://schemas.microsoft.com/office/drawing/2014/main" id="{6A934F21-97B2-45F3-BFAE-F912D34A6F43}"/>
+                <a16:creationId xmlns:a16="http://schemas.microsoft.com/office/drawing/2014/main" id="{D1368AA3-5B29-4C3E-AECB-955BAC0D41D4}"/>
               </a:ext>
             </a:extLst>
           </p:cNvPr>
@@ -16144,7 +16154,7 @@
     </p:spTree>
     <p:extLst>
       <p:ext uri="{BB962C8B-B14F-4D97-AF65-F5344CB8AC3E}">
-        <p14:creationId xmlns:p14="http://schemas.microsoft.com/office/powerpoint/2010/main" val="826064666"/>
+        <p14:creationId xmlns:p14="http://schemas.microsoft.com/office/powerpoint/2010/main" val="1781956122"/>
       </p:ext>
     </p:extLst>
   </p:cSld>
@@ -16175,7 +16185,7 @@
           <p:cNvPr id="6" name="">
             <a:extLst xmlns:a="http://schemas.openxmlformats.org/drawingml/2006/main">
               <a:ext uri="{FF2B5EF4-FFF2-40B4-BE49-F238E27FC236}">
-                <a16:creationId xmlns:a16="http://schemas.microsoft.com/office/drawing/2014/main" id="{F2717CB7-99CF-4BDC-B652-B7B5DA9B6DD5}"/>
+                <a16:creationId xmlns:a16="http://schemas.microsoft.com/office/drawing/2014/main" id="{B8EE40F4-1AF4-4F3B-94EF-1BDFF8952F83}"/>
               </a:ext>
             </a:extLst>
           </p:cNvPr>
@@ -16333,7 +16343,7 @@
           <p:cNvPr id="2" name="">
             <a:extLst xmlns:a="http://schemas.openxmlformats.org/drawingml/2006/main">
               <a:ext uri="{FF2B5EF4-FFF2-40B4-BE49-F238E27FC236}">
-                <a16:creationId xmlns:a16="http://schemas.microsoft.com/office/drawing/2014/main" id="{4946E7B1-A1D6-4BB3-B9E3-68F054E42620}"/>
+                <a16:creationId xmlns:a16="http://schemas.microsoft.com/office/drawing/2014/main" id="{FE58F2F6-6026-4AFD-9BF5-875B95318BC4}"/>
               </a:ext>
             </a:extLst>
           </p:cNvPr>
@@ -16491,7 +16501,7 @@
           <p:cNvPr id="3" name="">
             <a:extLst xmlns:a="http://schemas.openxmlformats.org/drawingml/2006/main">
               <a:ext uri="{FF2B5EF4-FFF2-40B4-BE49-F238E27FC236}">
-                <a16:creationId xmlns:a16="http://schemas.microsoft.com/office/drawing/2014/main" id="{46928139-FE42-4950-B4F7-85F7276D8268}"/>
+                <a16:creationId xmlns:a16="http://schemas.microsoft.com/office/drawing/2014/main" id="{9BE9A251-4BCF-47E3-ADEA-3D830791CE17}"/>
               </a:ext>
             </a:extLst>
           </p:cNvPr>
@@ -17257,7 +17267,7 @@
           <p:cNvPr id="4" name="">
             <a:extLst xmlns:a="http://schemas.openxmlformats.org/drawingml/2006/main">
               <a:ext uri="{FF2B5EF4-FFF2-40B4-BE49-F238E27FC236}">
-                <a16:creationId xmlns:a16="http://schemas.microsoft.com/office/drawing/2014/main" id="{2DFCC7FB-1ACC-47A5-B1D7-26C7BE2F99D5}"/>
+                <a16:creationId xmlns:a16="http://schemas.microsoft.com/office/drawing/2014/main" id="{E661E70C-359E-4B38-A772-FE6B2B80D385}"/>
               </a:ext>
             </a:extLst>
           </p:cNvPr>
@@ -17438,7 +17448,7 @@
           <p:cNvPr id="5" name="">
             <a:extLst xmlns:a="http://schemas.openxmlformats.org/drawingml/2006/main">
               <a:ext uri="{FF2B5EF4-FFF2-40B4-BE49-F238E27FC236}">
-                <a16:creationId xmlns:a16="http://schemas.microsoft.com/office/drawing/2014/main" id="{B0035A44-DCA5-40C6-8CF0-528F1E96CE03}"/>
+                <a16:creationId xmlns:a16="http://schemas.microsoft.com/office/drawing/2014/main" id="{FB43CC9B-BA1F-4AA6-B900-2E03650305FC}"/>
               </a:ext>
             </a:extLst>
           </p:cNvPr>
@@ -17594,7 +17604,7 @@
     </p:spTree>
     <p:extLst>
       <p:ext uri="{BB962C8B-B14F-4D97-AF65-F5344CB8AC3E}">
-        <p14:creationId xmlns:p14="http://schemas.microsoft.com/office/powerpoint/2010/main" val="1400976076"/>
+        <p14:creationId xmlns:p14="http://schemas.microsoft.com/office/powerpoint/2010/main" val="18161580"/>
       </p:ext>
     </p:extLst>
   </p:cSld>
@@ -17625,7 +17635,7 @@
           <p:cNvPr id="7" name="">
             <a:extLst xmlns:a="http://schemas.openxmlformats.org/drawingml/2006/main">
               <a:ext uri="{FF2B5EF4-FFF2-40B4-BE49-F238E27FC236}">
-                <a16:creationId xmlns:a16="http://schemas.microsoft.com/office/drawing/2014/main" id="{A6BC20B3-3281-4371-8D9B-7C3D25AC16D9}"/>
+                <a16:creationId xmlns:a16="http://schemas.microsoft.com/office/drawing/2014/main" id="{6A62B477-F429-40D0-997D-ADD176E85E6C}"/>
               </a:ext>
             </a:extLst>
           </p:cNvPr>
@@ -17783,7 +17793,7 @@
           <p:cNvPr id="2" name="">
             <a:extLst xmlns:a="http://schemas.openxmlformats.org/drawingml/2006/main">
               <a:ext uri="{FF2B5EF4-FFF2-40B4-BE49-F238E27FC236}">
-                <a16:creationId xmlns:a16="http://schemas.microsoft.com/office/drawing/2014/main" id="{6C442340-54BA-4B72-BF3A-1DD81AD90346}"/>
+                <a16:creationId xmlns:a16="http://schemas.microsoft.com/office/drawing/2014/main" id="{A9BF57A0-CC98-43E9-BBF6-E7F7FE6DD268}"/>
               </a:ext>
             </a:extLst>
           </p:cNvPr>
@@ -17941,7 +17951,7 @@
           <p:cNvPr id="3" name="">
             <a:extLst xmlns:a="http://schemas.openxmlformats.org/drawingml/2006/main">
               <a:ext uri="{FF2B5EF4-FFF2-40B4-BE49-F238E27FC236}">
-                <a16:creationId xmlns:a16="http://schemas.microsoft.com/office/drawing/2014/main" id="{22636DB8-2757-413F-94B2-A0715831B9D4}"/>
+                <a16:creationId xmlns:a16="http://schemas.microsoft.com/office/drawing/2014/main" id="{119F091A-58BF-49A3-BA64-AAACF5EE3422}"/>
               </a:ext>
             </a:extLst>
           </p:cNvPr>
@@ -17951,7 +17961,7 @@
           <p:nvPr/>
         </p:nvPicPr>
         <p:blipFill>
-          <a:blip xmlns:r="http://schemas.openxmlformats.org/officeDocument/2006/relationships" xmlns:a="http://schemas.openxmlformats.org/drawingml/2006/main" r:embed="R6fa42bd5274f4b3f"/>
+          <a:blip xmlns:r="http://schemas.openxmlformats.org/officeDocument/2006/relationships" xmlns:a="http://schemas.openxmlformats.org/drawingml/2006/main" r:embed="Rd709d71f5b5d411d"/>
           <a:stretch xmlns:a="http://schemas.openxmlformats.org/drawingml/2006/main"/>
         </p:blipFill>
         <p:spPr>
@@ -17969,7 +17979,7 @@
           <p:cNvPr id="4" name="">
             <a:extLst xmlns:a="http://schemas.openxmlformats.org/drawingml/2006/main">
               <a:ext uri="{FF2B5EF4-FFF2-40B4-BE49-F238E27FC236}">
-                <a16:creationId xmlns:a16="http://schemas.microsoft.com/office/drawing/2014/main" id="{59C77562-9CE1-47BC-A82D-604DC562AAAD}"/>
+                <a16:creationId xmlns:a16="http://schemas.microsoft.com/office/drawing/2014/main" id="{DF8EAED4-B302-4544-B8E1-28606A3E9047}"/>
               </a:ext>
             </a:extLst>
           </p:cNvPr>
@@ -18155,7 +18165,7 @@
           <p:cNvPr id="5" name="">
             <a:extLst xmlns:a="http://schemas.openxmlformats.org/drawingml/2006/main">
               <a:ext uri="{FF2B5EF4-FFF2-40B4-BE49-F238E27FC236}">
-                <a16:creationId xmlns:a16="http://schemas.microsoft.com/office/drawing/2014/main" id="{E6F7F167-2A2B-4E36-86D8-7DEFCA9290FF}"/>
+                <a16:creationId xmlns:a16="http://schemas.microsoft.com/office/drawing/2014/main" id="{D99C2B80-04CC-47E4-AA59-63EC6DC7AAF7}"/>
               </a:ext>
             </a:extLst>
           </p:cNvPr>
@@ -18313,7 +18323,7 @@
           <p:cNvPr id="6" name="">
             <a:extLst xmlns:a="http://schemas.openxmlformats.org/drawingml/2006/main">
               <a:ext uri="{FF2B5EF4-FFF2-40B4-BE49-F238E27FC236}">
-                <a16:creationId xmlns:a16="http://schemas.microsoft.com/office/drawing/2014/main" id="{05035DE5-AAF2-465C-8282-79906DD93390}"/>
+                <a16:creationId xmlns:a16="http://schemas.microsoft.com/office/drawing/2014/main" id="{E5662669-1DF2-47C3-A148-DEF588262163}"/>
               </a:ext>
             </a:extLst>
           </p:cNvPr>
@@ -18469,7 +18479,7 @@
     </p:spTree>
     <p:extLst>
       <p:ext uri="{BB962C8B-B14F-4D97-AF65-F5344CB8AC3E}">
-        <p14:creationId xmlns:p14="http://schemas.microsoft.com/office/powerpoint/2010/main" val="1290650694"/>
+        <p14:creationId xmlns:p14="http://schemas.microsoft.com/office/powerpoint/2010/main" val="633366875"/>
       </p:ext>
     </p:extLst>
   </p:cSld>
@@ -18500,7 +18510,7 @@
           <p:cNvPr id="7" name="">
             <a:extLst xmlns:a="http://schemas.openxmlformats.org/drawingml/2006/main">
               <a:ext uri="{FF2B5EF4-FFF2-40B4-BE49-F238E27FC236}">
-                <a16:creationId xmlns:a16="http://schemas.microsoft.com/office/drawing/2014/main" id="{A07618A8-E109-453F-B6E6-E9951F284110}"/>
+                <a16:creationId xmlns:a16="http://schemas.microsoft.com/office/drawing/2014/main" id="{A62660A3-963D-49E4-B256-3D7730251741}"/>
               </a:ext>
             </a:extLst>
           </p:cNvPr>
@@ -18658,7 +18668,7 @@
           <p:cNvPr id="2" name="">
             <a:extLst xmlns:a="http://schemas.openxmlformats.org/drawingml/2006/main">
               <a:ext uri="{FF2B5EF4-FFF2-40B4-BE49-F238E27FC236}">
-                <a16:creationId xmlns:a16="http://schemas.microsoft.com/office/drawing/2014/main" id="{AB0AA202-1D8A-454C-85E5-FA5D4833DDA7}"/>
+                <a16:creationId xmlns:a16="http://schemas.microsoft.com/office/drawing/2014/main" id="{21807134-DB92-4723-8ADF-72D90E3E05C2}"/>
               </a:ext>
             </a:extLst>
           </p:cNvPr>
@@ -18816,7 +18826,7 @@
           <p:cNvPr id="3" name="">
             <a:extLst xmlns:a="http://schemas.openxmlformats.org/drawingml/2006/main">
               <a:ext uri="{FF2B5EF4-FFF2-40B4-BE49-F238E27FC236}">
-                <a16:creationId xmlns:a16="http://schemas.microsoft.com/office/drawing/2014/main" id="{F4BF3637-51E1-4A44-A474-5BB0AEFA1A9F}"/>
+                <a16:creationId xmlns:a16="http://schemas.microsoft.com/office/drawing/2014/main" id="{E2596826-E74C-416F-96F9-C376DD3B66FE}"/>
               </a:ext>
             </a:extLst>
           </p:cNvPr>
@@ -18826,7 +18836,7 @@
           <p:nvPr/>
         </p:nvPicPr>
         <p:blipFill>
-          <a:blip xmlns:r="http://schemas.openxmlformats.org/officeDocument/2006/relationships" xmlns:a="http://schemas.openxmlformats.org/drawingml/2006/main" r:embed="R55aba7daa2b4495f"/>
+          <a:blip xmlns:r="http://schemas.openxmlformats.org/officeDocument/2006/relationships" xmlns:a="http://schemas.openxmlformats.org/drawingml/2006/main" r:embed="R4e4751fcb4ab4069"/>
           <a:stretch xmlns:a="http://schemas.openxmlformats.org/drawingml/2006/main"/>
         </p:blipFill>
         <p:spPr>
@@ -18844,7 +18854,7 @@
           <p:cNvPr id="4" name="">
             <a:extLst xmlns:a="http://schemas.openxmlformats.org/drawingml/2006/main">
               <a:ext uri="{FF2B5EF4-FFF2-40B4-BE49-F238E27FC236}">
-                <a16:creationId xmlns:a16="http://schemas.microsoft.com/office/drawing/2014/main" id="{12A58849-25FA-477F-8E52-D12EB44F4570}"/>
+                <a16:creationId xmlns:a16="http://schemas.microsoft.com/office/drawing/2014/main" id="{99463023-E411-4C7C-BD51-F979CD7D29D3}"/>
               </a:ext>
             </a:extLst>
           </p:cNvPr>
@@ -19030,7 +19040,7 @@
           <p:cNvPr id="5" name="">
             <a:extLst xmlns:a="http://schemas.openxmlformats.org/drawingml/2006/main">
               <a:ext uri="{FF2B5EF4-FFF2-40B4-BE49-F238E27FC236}">
-                <a16:creationId xmlns:a16="http://schemas.microsoft.com/office/drawing/2014/main" id="{FB2C753C-FFDE-4A55-9BA4-C3413D9E4137}"/>
+                <a16:creationId xmlns:a16="http://schemas.microsoft.com/office/drawing/2014/main" id="{1E9CD183-82D2-403C-9635-66869A5709D2}"/>
               </a:ext>
             </a:extLst>
           </p:cNvPr>
@@ -19188,7 +19198,7 @@
           <p:cNvPr id="6" name="">
             <a:extLst xmlns:a="http://schemas.openxmlformats.org/drawingml/2006/main">
               <a:ext uri="{FF2B5EF4-FFF2-40B4-BE49-F238E27FC236}">
-                <a16:creationId xmlns:a16="http://schemas.microsoft.com/office/drawing/2014/main" id="{D15446D1-4E15-45F1-B8EB-BFB9E5AD0B84}"/>
+                <a16:creationId xmlns:a16="http://schemas.microsoft.com/office/drawing/2014/main" id="{B51B37EB-EFE2-4EB5-B335-BEEB4922E1C3}"/>
               </a:ext>
             </a:extLst>
           </p:cNvPr>
@@ -19344,7 +19354,7 @@
     </p:spTree>
     <p:extLst>
       <p:ext uri="{BB962C8B-B14F-4D97-AF65-F5344CB8AC3E}">
-        <p14:creationId xmlns:p14="http://schemas.microsoft.com/office/powerpoint/2010/main" val="751701409"/>
+        <p14:creationId xmlns:p14="http://schemas.microsoft.com/office/powerpoint/2010/main" val="1916688762"/>
       </p:ext>
     </p:extLst>
   </p:cSld>
@@ -19375,7 +19385,7 @@
           <p:cNvPr id="7" name="">
             <a:extLst xmlns:a="http://schemas.openxmlformats.org/drawingml/2006/main">
               <a:ext uri="{FF2B5EF4-FFF2-40B4-BE49-F238E27FC236}">
-                <a16:creationId xmlns:a16="http://schemas.microsoft.com/office/drawing/2014/main" id="{3146855B-0405-44EA-9E21-82A6C4E9AEEA}"/>
+                <a16:creationId xmlns:a16="http://schemas.microsoft.com/office/drawing/2014/main" id="{857C9FCC-3F15-4299-BA83-040C084363A6}"/>
               </a:ext>
             </a:extLst>
           </p:cNvPr>
@@ -19533,7 +19543,7 @@
           <p:cNvPr id="2" name="">
             <a:extLst xmlns:a="http://schemas.openxmlformats.org/drawingml/2006/main">
               <a:ext uri="{FF2B5EF4-FFF2-40B4-BE49-F238E27FC236}">
-                <a16:creationId xmlns:a16="http://schemas.microsoft.com/office/drawing/2014/main" id="{4F80F129-BD92-42D3-8E2D-E497C5DBDFBD}"/>
+                <a16:creationId xmlns:a16="http://schemas.microsoft.com/office/drawing/2014/main" id="{A5975BF6-C43F-4037-9D21-7C11EEB9AA3E}"/>
               </a:ext>
             </a:extLst>
           </p:cNvPr>
@@ -19691,7 +19701,7 @@
           <p:cNvPr id="3" name="">
             <a:extLst xmlns:a="http://schemas.openxmlformats.org/drawingml/2006/main">
               <a:ext uri="{FF2B5EF4-FFF2-40B4-BE49-F238E27FC236}">
-                <a16:creationId xmlns:a16="http://schemas.microsoft.com/office/drawing/2014/main" id="{BE863A36-16E7-4BC5-91AD-B7A7843F2AB8}"/>
+                <a16:creationId xmlns:a16="http://schemas.microsoft.com/office/drawing/2014/main" id="{F1386A67-BEFF-4407-8C32-98310BD37925}"/>
               </a:ext>
             </a:extLst>
           </p:cNvPr>
@@ -19701,7 +19711,7 @@
           <p:nvPr/>
         </p:nvPicPr>
         <p:blipFill>
-          <a:blip xmlns:r="http://schemas.openxmlformats.org/officeDocument/2006/relationships" xmlns:a="http://schemas.openxmlformats.org/drawingml/2006/main" r:embed="R7bc60a6ed4694360"/>
+          <a:blip xmlns:r="http://schemas.openxmlformats.org/officeDocument/2006/relationships" xmlns:a="http://schemas.openxmlformats.org/drawingml/2006/main" r:embed="R8ccd25a3bdf64832"/>
           <a:stretch xmlns:a="http://schemas.openxmlformats.org/drawingml/2006/main"/>
         </p:blipFill>
         <p:spPr>
@@ -19719,7 +19729,7 @@
           <p:cNvPr id="4" name="">
             <a:extLst xmlns:a="http://schemas.openxmlformats.org/drawingml/2006/main">
               <a:ext uri="{FF2B5EF4-FFF2-40B4-BE49-F238E27FC236}">
-                <a16:creationId xmlns:a16="http://schemas.microsoft.com/office/drawing/2014/main" id="{257855ED-6CE4-4952-B30B-174BA4D0FBFA}"/>
+                <a16:creationId xmlns:a16="http://schemas.microsoft.com/office/drawing/2014/main" id="{939D6D49-D7B4-47ED-BD2C-F77FC24E9CED}"/>
               </a:ext>
             </a:extLst>
           </p:cNvPr>
@@ -19905,7 +19915,7 @@
           <p:cNvPr id="5" name="">
             <a:extLst xmlns:a="http://schemas.openxmlformats.org/drawingml/2006/main">
               <a:ext uri="{FF2B5EF4-FFF2-40B4-BE49-F238E27FC236}">
-                <a16:creationId xmlns:a16="http://schemas.microsoft.com/office/drawing/2014/main" id="{D8602E2E-D48D-4BE0-AE75-6A46D9F44284}"/>
+                <a16:creationId xmlns:a16="http://schemas.microsoft.com/office/drawing/2014/main" id="{59A11337-E605-4F60-9FB3-4135812A2333}"/>
               </a:ext>
             </a:extLst>
           </p:cNvPr>
@@ -20063,7 +20073,7 @@
           <p:cNvPr id="6" name="">
             <a:extLst xmlns:a="http://schemas.openxmlformats.org/drawingml/2006/main">
               <a:ext uri="{FF2B5EF4-FFF2-40B4-BE49-F238E27FC236}">
-                <a16:creationId xmlns:a16="http://schemas.microsoft.com/office/drawing/2014/main" id="{0A61BE5F-5F0A-4FF2-A9C3-0570904B1206}"/>
+                <a16:creationId xmlns:a16="http://schemas.microsoft.com/office/drawing/2014/main" id="{F425804A-C6C7-4822-85E8-A3F68746D7A6}"/>
               </a:ext>
             </a:extLst>
           </p:cNvPr>
@@ -20219,7 +20229,7 @@
     </p:spTree>
     <p:extLst>
       <p:ext uri="{BB962C8B-B14F-4D97-AF65-F5344CB8AC3E}">
-        <p14:creationId xmlns:p14="http://schemas.microsoft.com/office/powerpoint/2010/main" val="54652358"/>
+        <p14:creationId xmlns:p14="http://schemas.microsoft.com/office/powerpoint/2010/main" val="1984869186"/>
       </p:ext>
     </p:extLst>
   </p:cSld>
@@ -20250,7 +20260,7 @@
           <p:cNvPr id="7" name="">
             <a:extLst xmlns:a="http://schemas.openxmlformats.org/drawingml/2006/main">
               <a:ext uri="{FF2B5EF4-FFF2-40B4-BE49-F238E27FC236}">
-                <a16:creationId xmlns:a16="http://schemas.microsoft.com/office/drawing/2014/main" id="{79005ACD-C567-41A1-A399-C787C65D1014}"/>
+                <a16:creationId xmlns:a16="http://schemas.microsoft.com/office/drawing/2014/main" id="{E9E552EC-B181-4552-8469-89BD9BD1EC2F}"/>
               </a:ext>
             </a:extLst>
           </p:cNvPr>
@@ -20408,7 +20418,7 @@
           <p:cNvPr id="2" name="">
             <a:extLst xmlns:a="http://schemas.openxmlformats.org/drawingml/2006/main">
               <a:ext uri="{FF2B5EF4-FFF2-40B4-BE49-F238E27FC236}">
-                <a16:creationId xmlns:a16="http://schemas.microsoft.com/office/drawing/2014/main" id="{60265DC0-8788-48F0-B1A7-7B07052C7D52}"/>
+                <a16:creationId xmlns:a16="http://schemas.microsoft.com/office/drawing/2014/main" id="{116ED384-BC99-4934-8275-56BD5A2DC9D7}"/>
               </a:ext>
             </a:extLst>
           </p:cNvPr>
@@ -20566,7 +20576,7 @@
           <p:cNvPr id="3" name="">
             <a:extLst xmlns:a="http://schemas.openxmlformats.org/drawingml/2006/main">
               <a:ext uri="{FF2B5EF4-FFF2-40B4-BE49-F238E27FC236}">
-                <a16:creationId xmlns:a16="http://schemas.microsoft.com/office/drawing/2014/main" id="{34C549C2-ABC7-4CC2-AEE8-944F4EE406FB}"/>
+                <a16:creationId xmlns:a16="http://schemas.microsoft.com/office/drawing/2014/main" id="{F7051B9B-08C7-401B-83AB-055C9B265289}"/>
               </a:ext>
             </a:extLst>
           </p:cNvPr>
@@ -20576,7 +20586,7 @@
           <p:nvPr/>
         </p:nvPicPr>
         <p:blipFill>
-          <a:blip xmlns:r="http://schemas.openxmlformats.org/officeDocument/2006/relationships" xmlns:a="http://schemas.openxmlformats.org/drawingml/2006/main" r:embed="Ra2efa3af8d834c08"/>
+          <a:blip xmlns:r="http://schemas.openxmlformats.org/officeDocument/2006/relationships" xmlns:a="http://schemas.openxmlformats.org/drawingml/2006/main" r:embed="R7c2aef5722194e41"/>
           <a:stretch xmlns:a="http://schemas.openxmlformats.org/drawingml/2006/main"/>
         </p:blipFill>
         <p:spPr>
@@ -20594,7 +20604,7 @@
           <p:cNvPr id="4" name="">
             <a:extLst xmlns:a="http://schemas.openxmlformats.org/drawingml/2006/main">
               <a:ext uri="{FF2B5EF4-FFF2-40B4-BE49-F238E27FC236}">
-                <a16:creationId xmlns:a16="http://schemas.microsoft.com/office/drawing/2014/main" id="{F536563F-9B9C-49F8-8FA8-333187712324}"/>
+                <a16:creationId xmlns:a16="http://schemas.microsoft.com/office/drawing/2014/main" id="{B2002125-B6C5-49ED-A809-CA6A60DCB9D4}"/>
               </a:ext>
             </a:extLst>
           </p:cNvPr>
@@ -20780,7 +20790,7 @@
           <p:cNvPr id="5" name="">
             <a:extLst xmlns:a="http://schemas.openxmlformats.org/drawingml/2006/main">
               <a:ext uri="{FF2B5EF4-FFF2-40B4-BE49-F238E27FC236}">
-                <a16:creationId xmlns:a16="http://schemas.microsoft.com/office/drawing/2014/main" id="{5E30F0A4-E865-491B-85CA-6F21AFF8A71A}"/>
+                <a16:creationId xmlns:a16="http://schemas.microsoft.com/office/drawing/2014/main" id="{B4B7BC0E-6518-4FE6-9C97-DEC034AAFE09}"/>
               </a:ext>
             </a:extLst>
           </p:cNvPr>
@@ -20938,7 +20948,7 @@
           <p:cNvPr id="6" name="">
             <a:extLst xmlns:a="http://schemas.openxmlformats.org/drawingml/2006/main">
               <a:ext uri="{FF2B5EF4-FFF2-40B4-BE49-F238E27FC236}">
-                <a16:creationId xmlns:a16="http://schemas.microsoft.com/office/drawing/2014/main" id="{EF0F871D-7784-4100-8119-556D24012689}"/>
+                <a16:creationId xmlns:a16="http://schemas.microsoft.com/office/drawing/2014/main" id="{66202E2A-8E96-43AE-A47A-3D11EE8E5308}"/>
               </a:ext>
             </a:extLst>
           </p:cNvPr>
@@ -21094,7 +21104,7 @@
     </p:spTree>
     <p:extLst>
       <p:ext uri="{BB962C8B-B14F-4D97-AF65-F5344CB8AC3E}">
-        <p14:creationId xmlns:p14="http://schemas.microsoft.com/office/powerpoint/2010/main" val="1181613779"/>
+        <p14:creationId xmlns:p14="http://schemas.microsoft.com/office/powerpoint/2010/main" val="954284152"/>
       </p:ext>
     </p:extLst>
   </p:cSld>
@@ -21125,7 +21135,7 @@
           <p:cNvPr id="7" name="">
             <a:extLst xmlns:a="http://schemas.openxmlformats.org/drawingml/2006/main">
               <a:ext uri="{FF2B5EF4-FFF2-40B4-BE49-F238E27FC236}">
-                <a16:creationId xmlns:a16="http://schemas.microsoft.com/office/drawing/2014/main" id="{3769422B-7A6D-4B18-92ED-7B658AE655C2}"/>
+                <a16:creationId xmlns:a16="http://schemas.microsoft.com/office/drawing/2014/main" id="{D275D1A2-F72A-4496-B786-A570E1AB12C0}"/>
               </a:ext>
             </a:extLst>
           </p:cNvPr>
@@ -21283,7 +21293,7 @@
           <p:cNvPr id="2" name="">
             <a:extLst xmlns:a="http://schemas.openxmlformats.org/drawingml/2006/main">
               <a:ext uri="{FF2B5EF4-FFF2-40B4-BE49-F238E27FC236}">
-                <a16:creationId xmlns:a16="http://schemas.microsoft.com/office/drawing/2014/main" id="{19CCE496-81D5-4DFB-80A5-29F945E32F1F}"/>
+                <a16:creationId xmlns:a16="http://schemas.microsoft.com/office/drawing/2014/main" id="{E1EC32BE-12B3-4572-8541-DBBCF26006FF}"/>
               </a:ext>
             </a:extLst>
           </p:cNvPr>
@@ -21441,7 +21451,7 @@
           <p:cNvPr id="3" name="">
             <a:extLst xmlns:a="http://schemas.openxmlformats.org/drawingml/2006/main">
               <a:ext uri="{FF2B5EF4-FFF2-40B4-BE49-F238E27FC236}">
-                <a16:creationId xmlns:a16="http://schemas.microsoft.com/office/drawing/2014/main" id="{3D25E05F-4AB8-45E0-A33D-D95EA3FC4330}"/>
+                <a16:creationId xmlns:a16="http://schemas.microsoft.com/office/drawing/2014/main" id="{35F4A849-C707-490C-B356-B9F25A957388}"/>
               </a:ext>
             </a:extLst>
           </p:cNvPr>
@@ -21451,7 +21461,7 @@
           <p:nvPr/>
         </p:nvPicPr>
         <p:blipFill>
-          <a:blip xmlns:r="http://schemas.openxmlformats.org/officeDocument/2006/relationships" xmlns:a="http://schemas.openxmlformats.org/drawingml/2006/main" r:embed="R0c8cee7f922b4c71"/>
+          <a:blip xmlns:r="http://schemas.openxmlformats.org/officeDocument/2006/relationships" xmlns:a="http://schemas.openxmlformats.org/drawingml/2006/main" r:embed="Rfacd0802c3fe4fd2"/>
           <a:stretch xmlns:a="http://schemas.openxmlformats.org/drawingml/2006/main"/>
         </p:blipFill>
         <p:spPr>
@@ -21469,7 +21479,7 @@
           <p:cNvPr id="4" name="">
             <a:extLst xmlns:a="http://schemas.openxmlformats.org/drawingml/2006/main">
               <a:ext uri="{FF2B5EF4-FFF2-40B4-BE49-F238E27FC236}">
-                <a16:creationId xmlns:a16="http://schemas.microsoft.com/office/drawing/2014/main" id="{F80843E9-98A4-413A-9498-EF1A6691B25C}"/>
+                <a16:creationId xmlns:a16="http://schemas.microsoft.com/office/drawing/2014/main" id="{6DF8070A-74B3-43F0-AC21-4EE3C9103E7F}"/>
               </a:ext>
             </a:extLst>
           </p:cNvPr>
@@ -21655,7 +21665,7 @@
           <p:cNvPr id="5" name="">
             <a:extLst xmlns:a="http://schemas.openxmlformats.org/drawingml/2006/main">
               <a:ext uri="{FF2B5EF4-FFF2-40B4-BE49-F238E27FC236}">
-                <a16:creationId xmlns:a16="http://schemas.microsoft.com/office/drawing/2014/main" id="{246CA5BA-DA05-4A1E-82CA-CAE1E0123FE2}"/>
+                <a16:creationId xmlns:a16="http://schemas.microsoft.com/office/drawing/2014/main" id="{A8CEA2FC-4D2A-49F8-8619-5794270907C1}"/>
               </a:ext>
             </a:extLst>
           </p:cNvPr>
@@ -21813,7 +21823,7 @@
           <p:cNvPr id="6" name="">
             <a:extLst xmlns:a="http://schemas.openxmlformats.org/drawingml/2006/main">
               <a:ext uri="{FF2B5EF4-FFF2-40B4-BE49-F238E27FC236}">
-                <a16:creationId xmlns:a16="http://schemas.microsoft.com/office/drawing/2014/main" id="{90FB95D8-D3A5-46E7-9D35-EDBD0FDD8163}"/>
+                <a16:creationId xmlns:a16="http://schemas.microsoft.com/office/drawing/2014/main" id="{51C152D3-8086-41BC-8BD3-7DA34D0A383F}"/>
               </a:ext>
             </a:extLst>
           </p:cNvPr>
@@ -21969,7 +21979,7 @@
     </p:spTree>
     <p:extLst>
       <p:ext uri="{BB962C8B-B14F-4D97-AF65-F5344CB8AC3E}">
-        <p14:creationId xmlns:p14="http://schemas.microsoft.com/office/powerpoint/2010/main" val="361707425"/>
+        <p14:creationId xmlns:p14="http://schemas.microsoft.com/office/powerpoint/2010/main" val="2094541667"/>
       </p:ext>
     </p:extLst>
   </p:cSld>
@@ -22000,7 +22010,7 @@
           <p:cNvPr id="6" name="">
             <a:extLst xmlns:a="http://schemas.openxmlformats.org/drawingml/2006/main">
               <a:ext uri="{FF2B5EF4-FFF2-40B4-BE49-F238E27FC236}">
-                <a16:creationId xmlns:a16="http://schemas.microsoft.com/office/drawing/2014/main" id="{C82937A2-C849-4AA8-9072-0E67B6D3DED4}"/>
+                <a16:creationId xmlns:a16="http://schemas.microsoft.com/office/drawing/2014/main" id="{EEBA0A0B-4C38-438F-826C-34F01138B1DE}"/>
               </a:ext>
             </a:extLst>
           </p:cNvPr>
@@ -22158,7 +22168,7 @@
           <p:cNvPr id="2" name="">
             <a:extLst xmlns:a="http://schemas.openxmlformats.org/drawingml/2006/main">
               <a:ext uri="{FF2B5EF4-FFF2-40B4-BE49-F238E27FC236}">
-                <a16:creationId xmlns:a16="http://schemas.microsoft.com/office/drawing/2014/main" id="{01501D17-2237-4BE0-972B-052B9052AF6D}"/>
+                <a16:creationId xmlns:a16="http://schemas.microsoft.com/office/drawing/2014/main" id="{0C6B9843-2294-48BC-9F9F-6A514135D97D}"/>
               </a:ext>
             </a:extLst>
           </p:cNvPr>
@@ -22316,7 +22326,7 @@
           <p:cNvPr id="3" name="">
             <a:extLst xmlns:a="http://schemas.openxmlformats.org/drawingml/2006/main">
               <a:ext uri="{FF2B5EF4-FFF2-40B4-BE49-F238E27FC236}">
-                <a16:creationId xmlns:a16="http://schemas.microsoft.com/office/drawing/2014/main" id="{D936F856-089D-4ADA-8A65-360A2A8AE2D9}"/>
+                <a16:creationId xmlns:a16="http://schemas.microsoft.com/office/drawing/2014/main" id="{26B85F54-7B5A-4D5E-B314-7B5D5A8FCB34}"/>
               </a:ext>
             </a:extLst>
           </p:cNvPr>
@@ -22907,7 +22917,7 @@
           <p:cNvPr id="4" name="">
             <a:extLst xmlns:a="http://schemas.openxmlformats.org/drawingml/2006/main">
               <a:ext uri="{FF2B5EF4-FFF2-40B4-BE49-F238E27FC236}">
-                <a16:creationId xmlns:a16="http://schemas.microsoft.com/office/drawing/2014/main" id="{BAC2D918-E6C5-44B4-ADEF-321B27BF2B71}"/>
+                <a16:creationId xmlns:a16="http://schemas.microsoft.com/office/drawing/2014/main" id="{186308CA-90A4-4A56-A918-7ECA4C52AFF8}"/>
               </a:ext>
             </a:extLst>
           </p:cNvPr>
@@ -23088,7 +23098,7 @@
           <p:cNvPr id="5" name="">
             <a:extLst xmlns:a="http://schemas.openxmlformats.org/drawingml/2006/main">
               <a:ext uri="{FF2B5EF4-FFF2-40B4-BE49-F238E27FC236}">
-                <a16:creationId xmlns:a16="http://schemas.microsoft.com/office/drawing/2014/main" id="{7CAD8191-6DC0-404C-8620-67931B24905B}"/>
+                <a16:creationId xmlns:a16="http://schemas.microsoft.com/office/drawing/2014/main" id="{11E4AA3F-367C-428A-BBF9-D13A4A29FB03}"/>
               </a:ext>
             </a:extLst>
           </p:cNvPr>
@@ -23244,7 +23254,7 @@
     </p:spTree>
     <p:extLst>
       <p:ext uri="{BB962C8B-B14F-4D97-AF65-F5344CB8AC3E}">
-        <p14:creationId xmlns:p14="http://schemas.microsoft.com/office/powerpoint/2010/main" val="425986196"/>
+        <p14:creationId xmlns:p14="http://schemas.microsoft.com/office/powerpoint/2010/main" val="12100745"/>
       </p:ext>
     </p:extLst>
   </p:cSld>
@@ -23275,7 +23285,7 @@
           <p:cNvPr id="7" name="">
             <a:extLst xmlns:a="http://schemas.openxmlformats.org/drawingml/2006/main">
               <a:ext uri="{FF2B5EF4-FFF2-40B4-BE49-F238E27FC236}">
-                <a16:creationId xmlns:a16="http://schemas.microsoft.com/office/drawing/2014/main" id="{6CEDCD32-CE91-478A-A077-AEAC89513550}"/>
+                <a16:creationId xmlns:a16="http://schemas.microsoft.com/office/drawing/2014/main" id="{8277D60F-D0DB-40EF-9A38-7CC7450D98E0}"/>
               </a:ext>
             </a:extLst>
           </p:cNvPr>
@@ -23433,7 +23443,7 @@
           <p:cNvPr id="2" name="">
             <a:extLst xmlns:a="http://schemas.openxmlformats.org/drawingml/2006/main">
               <a:ext uri="{FF2B5EF4-FFF2-40B4-BE49-F238E27FC236}">
-                <a16:creationId xmlns:a16="http://schemas.microsoft.com/office/drawing/2014/main" id="{EF13053A-1ADB-4905-8CB3-6EF271B0251B}"/>
+                <a16:creationId xmlns:a16="http://schemas.microsoft.com/office/drawing/2014/main" id="{53F89E2A-30D7-4CB7-8725-4E131F4F298C}"/>
               </a:ext>
             </a:extLst>
           </p:cNvPr>
@@ -23591,7 +23601,7 @@
           <p:cNvPr id="3" name="">
             <a:extLst xmlns:a="http://schemas.openxmlformats.org/drawingml/2006/main">
               <a:ext uri="{FF2B5EF4-FFF2-40B4-BE49-F238E27FC236}">
-                <a16:creationId xmlns:a16="http://schemas.microsoft.com/office/drawing/2014/main" id="{E66A989A-A69F-4B12-85B3-37E436FAEDDA}"/>
+                <a16:creationId xmlns:a16="http://schemas.microsoft.com/office/drawing/2014/main" id="{8AB5E91A-B56B-4F30-A110-189049955E1D}"/>
               </a:ext>
             </a:extLst>
           </p:cNvPr>
@@ -23601,7 +23611,7 @@
           <p:nvPr/>
         </p:nvPicPr>
         <p:blipFill>
-          <a:blip xmlns:r="http://schemas.openxmlformats.org/officeDocument/2006/relationships" xmlns:a="http://schemas.openxmlformats.org/drawingml/2006/main" r:embed="R23eac1f2ee7f4291"/>
+          <a:blip xmlns:r="http://schemas.openxmlformats.org/officeDocument/2006/relationships" xmlns:a="http://schemas.openxmlformats.org/drawingml/2006/main" r:embed="Rca341e281703449d"/>
           <a:stretch xmlns:a="http://schemas.openxmlformats.org/drawingml/2006/main"/>
         </p:blipFill>
         <p:spPr>
@@ -23619,7 +23629,7 @@
           <p:cNvPr id="4" name="">
             <a:extLst xmlns:a="http://schemas.openxmlformats.org/drawingml/2006/main">
               <a:ext uri="{FF2B5EF4-FFF2-40B4-BE49-F238E27FC236}">
-                <a16:creationId xmlns:a16="http://schemas.microsoft.com/office/drawing/2014/main" id="{D8907148-0B32-4FCF-AE59-A81BCCD6774B}"/>
+                <a16:creationId xmlns:a16="http://schemas.microsoft.com/office/drawing/2014/main" id="{3ADD946F-7DDF-4B1D-84E6-54D6BDFB3FE9}"/>
               </a:ext>
             </a:extLst>
           </p:cNvPr>
@@ -23805,7 +23815,7 @@
           <p:cNvPr id="5" name="">
             <a:extLst xmlns:a="http://schemas.openxmlformats.org/drawingml/2006/main">
               <a:ext uri="{FF2B5EF4-FFF2-40B4-BE49-F238E27FC236}">
-                <a16:creationId xmlns:a16="http://schemas.microsoft.com/office/drawing/2014/main" id="{1C4A1C90-DFB9-4B07-84C8-8965F9ED6C18}"/>
+                <a16:creationId xmlns:a16="http://schemas.microsoft.com/office/drawing/2014/main" id="{CA0EF841-F2D9-4C2E-A045-BB3C76073647}"/>
               </a:ext>
             </a:extLst>
           </p:cNvPr>
@@ -23963,7 +23973,7 @@
           <p:cNvPr id="6" name="">
             <a:extLst xmlns:a="http://schemas.openxmlformats.org/drawingml/2006/main">
               <a:ext uri="{FF2B5EF4-FFF2-40B4-BE49-F238E27FC236}">
-                <a16:creationId xmlns:a16="http://schemas.microsoft.com/office/drawing/2014/main" id="{12FF3A05-8306-43D4-8C1E-812DFCFEED6B}"/>
+                <a16:creationId xmlns:a16="http://schemas.microsoft.com/office/drawing/2014/main" id="{61AD1D32-934A-4486-88C7-5BD4B0420D89}"/>
               </a:ext>
             </a:extLst>
           </p:cNvPr>
@@ -24119,7 +24129,7 @@
     </p:spTree>
     <p:extLst>
       <p:ext uri="{BB962C8B-B14F-4D97-AF65-F5344CB8AC3E}">
-        <p14:creationId xmlns:p14="http://schemas.microsoft.com/office/powerpoint/2010/main" val="203435784"/>
+        <p14:creationId xmlns:p14="http://schemas.microsoft.com/office/powerpoint/2010/main" val="1310935693"/>
       </p:ext>
     </p:extLst>
   </p:cSld>
@@ -24150,7 +24160,7 @@
           <p:cNvPr id="7" name="">
             <a:extLst xmlns:a="http://schemas.openxmlformats.org/drawingml/2006/main">
               <a:ext uri="{FF2B5EF4-FFF2-40B4-BE49-F238E27FC236}">
-                <a16:creationId xmlns:a16="http://schemas.microsoft.com/office/drawing/2014/main" id="{6CE0A565-542C-4BCB-9A4E-7E122172672E}"/>
+                <a16:creationId xmlns:a16="http://schemas.microsoft.com/office/drawing/2014/main" id="{9BA4F549-1968-4F41-9ADB-964430A61D2B}"/>
               </a:ext>
             </a:extLst>
           </p:cNvPr>
@@ -24308,7 +24318,7 @@
           <p:cNvPr id="2" name="">
             <a:extLst xmlns:a="http://schemas.openxmlformats.org/drawingml/2006/main">
               <a:ext uri="{FF2B5EF4-FFF2-40B4-BE49-F238E27FC236}">
-                <a16:creationId xmlns:a16="http://schemas.microsoft.com/office/drawing/2014/main" id="{86A498E1-4D28-4BF7-9EA2-BFDEF64AF5FA}"/>
+                <a16:creationId xmlns:a16="http://schemas.microsoft.com/office/drawing/2014/main" id="{17633A94-B60F-498E-B35F-9FB87A1B7AC6}"/>
               </a:ext>
             </a:extLst>
           </p:cNvPr>
@@ -24456,7 +24466,7 @@
                 <a:ea typeface="AppleGothic"/>
                 <a:cs typeface="AppleGothic"/>
               </a:rPr>
-              <a:t>복제된 spectrum이 겹치면 원래 주파수를 구별할 수 없다.</a:t>
+              <a:t>Fourier basis는 표본의 주파수 성분을 분석한다. Aliasing 방지는 표본화 전에 결정된다.</a:t>
             </a:r>
           </a:p>
         </p:txBody>
@@ -24466,7 +24476,7 @@
           <p:cNvPr id="3" name="">
             <a:extLst xmlns:a="http://schemas.openxmlformats.org/drawingml/2006/main">
               <a:ext uri="{FF2B5EF4-FFF2-40B4-BE49-F238E27FC236}">
-                <a16:creationId xmlns:a16="http://schemas.microsoft.com/office/drawing/2014/main" id="{6E5E9DFA-C9A5-4E1B-9E04-E407AAA22D5B}"/>
+                <a16:creationId xmlns:a16="http://schemas.microsoft.com/office/drawing/2014/main" id="{2BAB4247-6C5E-470E-AC31-F77E478BDBBF}"/>
               </a:ext>
             </a:extLst>
           </p:cNvPr>
@@ -24476,7 +24486,7 @@
           <p:nvPr/>
         </p:nvPicPr>
         <p:blipFill>
-          <a:blip xmlns:r="http://schemas.openxmlformats.org/officeDocument/2006/relationships" xmlns:a="http://schemas.openxmlformats.org/drawingml/2006/main" r:embed="R9b8b542798e94322"/>
+          <a:blip xmlns:r="http://schemas.openxmlformats.org/officeDocument/2006/relationships" xmlns:a="http://schemas.openxmlformats.org/drawingml/2006/main" r:embed="Rb4507dbb085a4f29"/>
           <a:stretch xmlns:a="http://schemas.openxmlformats.org/drawingml/2006/main"/>
         </p:blipFill>
         <p:spPr>
@@ -24494,7 +24504,7 @@
           <p:cNvPr id="4" name="">
             <a:extLst xmlns:a="http://schemas.openxmlformats.org/drawingml/2006/main">
               <a:ext uri="{FF2B5EF4-FFF2-40B4-BE49-F238E27FC236}">
-                <a16:creationId xmlns:a16="http://schemas.microsoft.com/office/drawing/2014/main" id="{92C04DF0-5E7B-4E62-9A86-6F4E367F350F}"/>
+                <a16:creationId xmlns:a16="http://schemas.microsoft.com/office/drawing/2014/main" id="{C216D845-0B4A-4191-B18E-3829781BBB0B}"/>
               </a:ext>
             </a:extLst>
           </p:cNvPr>
@@ -24642,7 +24652,7 @@
                 <a:ea typeface="AppleGothic"/>
                 <a:cs typeface="AppleGothic"/>
               </a:rPr>
-              <a:t>Band limit fmax를 일반적으로 복원하려면 fs&gt;2fmax를 사용한다.</a:t>
+              <a:t>fs=8 kHz에서 zero-phase 5 kHz와 3 kHz cosine은 같은 표본을 만든다: cos(2π·5n/8)=cos(2π·3n/8).</a:t>
             </a:r>
           </a:p>
           <a:p xmlns:a="http://schemas.openxmlformats.org/drawingml/2006/main">
@@ -24670,7 +24680,7 @@
                 <a:ea typeface="AppleGothic"/>
                 <a:cs typeface="AppleGothic"/>
               </a:rPr>
-              <a:t>8 kHz 표본화에서 7 kHz cosine은 1 kHz cosine과 같은 표본을 만든다. FFT 길이를 늘려도 구별 정보는 돌아오지 않는다.</a:t>
+              <a:t>표본화 전 anti-alias low-pass filter와 충분한 fs가 겹침을 막는다. FFT 길이나 window는 이미 잃은 원 주파수를 복원하지 못한다.</a:t>
             </a:r>
           </a:p>
         </p:txBody>
@@ -24680,7 +24690,7 @@
           <p:cNvPr id="5" name="">
             <a:extLst xmlns:a="http://schemas.openxmlformats.org/drawingml/2006/main">
               <a:ext uri="{FF2B5EF4-FFF2-40B4-BE49-F238E27FC236}">
-                <a16:creationId xmlns:a16="http://schemas.microsoft.com/office/drawing/2014/main" id="{30B81616-308E-47D5-8678-FB4A30DDFF6B}"/>
+                <a16:creationId xmlns:a16="http://schemas.microsoft.com/office/drawing/2014/main" id="{A794A97A-9DB3-4815-8BFF-FE9923135DE6}"/>
               </a:ext>
             </a:extLst>
           </p:cNvPr>
@@ -24838,7 +24848,7 @@
           <p:cNvPr id="6" name="">
             <a:extLst xmlns:a="http://schemas.openxmlformats.org/drawingml/2006/main">
               <a:ext uri="{FF2B5EF4-FFF2-40B4-BE49-F238E27FC236}">
-                <a16:creationId xmlns:a16="http://schemas.microsoft.com/office/drawing/2014/main" id="{4718CDB0-6211-4333-99C5-304AE00FDF3B}"/>
+                <a16:creationId xmlns:a16="http://schemas.microsoft.com/office/drawing/2014/main" id="{E5824214-55B0-4ECC-820C-22DC83BBC50A}"/>
               </a:ext>
             </a:extLst>
           </p:cNvPr>
@@ -24994,7 +25004,7 @@
     </p:spTree>
     <p:extLst>
       <p:ext uri="{BB962C8B-B14F-4D97-AF65-F5344CB8AC3E}">
-        <p14:creationId xmlns:p14="http://schemas.microsoft.com/office/powerpoint/2010/main" val="2078282311"/>
+        <p14:creationId xmlns:p14="http://schemas.microsoft.com/office/powerpoint/2010/main" val="1933953912"/>
       </p:ext>
     </p:extLst>
   </p:cSld>
@@ -25025,7 +25035,7 @@
           <p:cNvPr id="7" name="">
             <a:extLst xmlns:a="http://schemas.openxmlformats.org/drawingml/2006/main">
               <a:ext uri="{FF2B5EF4-FFF2-40B4-BE49-F238E27FC236}">
-                <a16:creationId xmlns:a16="http://schemas.microsoft.com/office/drawing/2014/main" id="{BA795F13-C51A-4955-A38F-FB8C9DE95B88}"/>
+                <a16:creationId xmlns:a16="http://schemas.microsoft.com/office/drawing/2014/main" id="{D8E94EB0-B7AC-4E4C-8B69-796522FB81E4}"/>
               </a:ext>
             </a:extLst>
           </p:cNvPr>
@@ -25183,7 +25193,7 @@
           <p:cNvPr id="2" name="">
             <a:extLst xmlns:a="http://schemas.openxmlformats.org/drawingml/2006/main">
               <a:ext uri="{FF2B5EF4-FFF2-40B4-BE49-F238E27FC236}">
-                <a16:creationId xmlns:a16="http://schemas.microsoft.com/office/drawing/2014/main" id="{7115ABA0-6C35-4AAA-9846-4F6FCAB03C6C}"/>
+                <a16:creationId xmlns:a16="http://schemas.microsoft.com/office/drawing/2014/main" id="{5FDB6B17-1B25-4197-8ED8-AD970983DD1E}"/>
               </a:ext>
             </a:extLst>
           </p:cNvPr>
@@ -25341,7 +25351,7 @@
           <p:cNvPr id="3" name="">
             <a:extLst xmlns:a="http://schemas.openxmlformats.org/drawingml/2006/main">
               <a:ext uri="{FF2B5EF4-FFF2-40B4-BE49-F238E27FC236}">
-                <a16:creationId xmlns:a16="http://schemas.microsoft.com/office/drawing/2014/main" id="{149C50C9-0513-4EFF-A708-DE228C671C24}"/>
+                <a16:creationId xmlns:a16="http://schemas.microsoft.com/office/drawing/2014/main" id="{7B8DDB42-B5C4-412D-9661-6B8C191337A3}"/>
               </a:ext>
             </a:extLst>
           </p:cNvPr>
@@ -25351,7 +25361,7 @@
           <p:nvPr/>
         </p:nvPicPr>
         <p:blipFill>
-          <a:blip xmlns:r="http://schemas.openxmlformats.org/officeDocument/2006/relationships" xmlns:a="http://schemas.openxmlformats.org/drawingml/2006/main" r:embed="Re122410d1ee747d0"/>
+          <a:blip xmlns:r="http://schemas.openxmlformats.org/officeDocument/2006/relationships" xmlns:a="http://schemas.openxmlformats.org/drawingml/2006/main" r:embed="R6dcf4c5738584632"/>
           <a:stretch xmlns:a="http://schemas.openxmlformats.org/drawingml/2006/main"/>
         </p:blipFill>
         <p:spPr>
@@ -25369,7 +25379,7 @@
           <p:cNvPr id="4" name="">
             <a:extLst xmlns:a="http://schemas.openxmlformats.org/drawingml/2006/main">
               <a:ext uri="{FF2B5EF4-FFF2-40B4-BE49-F238E27FC236}">
-                <a16:creationId xmlns:a16="http://schemas.microsoft.com/office/drawing/2014/main" id="{A43AD557-2FC9-4107-B8DD-76687487F65D}"/>
+                <a16:creationId xmlns:a16="http://schemas.microsoft.com/office/drawing/2014/main" id="{99B34FE7-3F90-4BC6-AA69-400BCB6CA116}"/>
               </a:ext>
             </a:extLst>
           </p:cNvPr>
@@ -25583,7 +25593,7 @@
           <p:cNvPr id="5" name="">
             <a:extLst xmlns:a="http://schemas.openxmlformats.org/drawingml/2006/main">
               <a:ext uri="{FF2B5EF4-FFF2-40B4-BE49-F238E27FC236}">
-                <a16:creationId xmlns:a16="http://schemas.microsoft.com/office/drawing/2014/main" id="{795292D7-8FF9-4873-8A90-8A9BDFCDC146}"/>
+                <a16:creationId xmlns:a16="http://schemas.microsoft.com/office/drawing/2014/main" id="{0F24414C-29DF-4C10-8C2C-7AF7AE384BF0}"/>
               </a:ext>
             </a:extLst>
           </p:cNvPr>
@@ -25741,7 +25751,7 @@
           <p:cNvPr id="6" name="">
             <a:extLst xmlns:a="http://schemas.openxmlformats.org/drawingml/2006/main">
               <a:ext uri="{FF2B5EF4-FFF2-40B4-BE49-F238E27FC236}">
-                <a16:creationId xmlns:a16="http://schemas.microsoft.com/office/drawing/2014/main" id="{203E839F-ACF5-49D5-82A3-4D014007BB80}"/>
+                <a16:creationId xmlns:a16="http://schemas.microsoft.com/office/drawing/2014/main" id="{6F2BA5C1-F729-462A-A5B7-3197A7FFF0D6}"/>
               </a:ext>
             </a:extLst>
           </p:cNvPr>
@@ -25897,7 +25907,7 @@
     </p:spTree>
     <p:extLst>
       <p:ext uri="{BB962C8B-B14F-4D97-AF65-F5344CB8AC3E}">
-        <p14:creationId xmlns:p14="http://schemas.microsoft.com/office/powerpoint/2010/main" val="301464780"/>
+        <p14:creationId xmlns:p14="http://schemas.microsoft.com/office/powerpoint/2010/main" val="1415898065"/>
       </p:ext>
     </p:extLst>
   </p:cSld>
@@ -25928,7 +25938,7 @@
           <p:cNvPr id="7" name="">
             <a:extLst xmlns:a="http://schemas.openxmlformats.org/drawingml/2006/main">
               <a:ext uri="{FF2B5EF4-FFF2-40B4-BE49-F238E27FC236}">
-                <a16:creationId xmlns:a16="http://schemas.microsoft.com/office/drawing/2014/main" id="{45EE45CB-4346-468C-9411-4CFA0F3DCA77}"/>
+                <a16:creationId xmlns:a16="http://schemas.microsoft.com/office/drawing/2014/main" id="{2EC5B003-E91A-4FE6-89F1-81266DAAFDCF}"/>
               </a:ext>
             </a:extLst>
           </p:cNvPr>
@@ -26086,7 +26096,7 @@
           <p:cNvPr id="2" name="">
             <a:extLst xmlns:a="http://schemas.openxmlformats.org/drawingml/2006/main">
               <a:ext uri="{FF2B5EF4-FFF2-40B4-BE49-F238E27FC236}">
-                <a16:creationId xmlns:a16="http://schemas.microsoft.com/office/drawing/2014/main" id="{42272886-EF01-4B8B-81FC-73F5621A03C0}"/>
+                <a16:creationId xmlns:a16="http://schemas.microsoft.com/office/drawing/2014/main" id="{223264C1-C28C-403A-8FFC-CF3643BE4846}"/>
               </a:ext>
             </a:extLst>
           </p:cNvPr>
@@ -26244,7 +26254,7 @@
           <p:cNvPr id="3" name="">
             <a:extLst xmlns:a="http://schemas.openxmlformats.org/drawingml/2006/main">
               <a:ext uri="{FF2B5EF4-FFF2-40B4-BE49-F238E27FC236}">
-                <a16:creationId xmlns:a16="http://schemas.microsoft.com/office/drawing/2014/main" id="{28E8D2B3-7B3B-4668-A519-D3F9B8239538}"/>
+                <a16:creationId xmlns:a16="http://schemas.microsoft.com/office/drawing/2014/main" id="{C7BAA144-E5D0-4845-9D85-B1CCF4B07FCF}"/>
               </a:ext>
             </a:extLst>
           </p:cNvPr>
@@ -26254,7 +26264,7 @@
           <p:nvPr/>
         </p:nvPicPr>
         <p:blipFill>
-          <a:blip xmlns:r="http://schemas.openxmlformats.org/officeDocument/2006/relationships" xmlns:a="http://schemas.openxmlformats.org/drawingml/2006/main" r:embed="R795c738e4a1b44b0"/>
+          <a:blip xmlns:r="http://schemas.openxmlformats.org/officeDocument/2006/relationships" xmlns:a="http://schemas.openxmlformats.org/drawingml/2006/main" r:embed="Rabf95076fe134a2a"/>
           <a:stretch xmlns:a="http://schemas.openxmlformats.org/drawingml/2006/main"/>
         </p:blipFill>
         <p:spPr>
@@ -26272,7 +26282,7 @@
           <p:cNvPr id="4" name="">
             <a:extLst xmlns:a="http://schemas.openxmlformats.org/drawingml/2006/main">
               <a:ext uri="{FF2B5EF4-FFF2-40B4-BE49-F238E27FC236}">
-                <a16:creationId xmlns:a16="http://schemas.microsoft.com/office/drawing/2014/main" id="{C2FEE0AE-F9D2-4BEE-A2AA-6DCDD61AF36D}"/>
+                <a16:creationId xmlns:a16="http://schemas.microsoft.com/office/drawing/2014/main" id="{6508DECB-F89F-41FE-A1A5-465B7CB6EDF5}"/>
               </a:ext>
             </a:extLst>
           </p:cNvPr>
@@ -26458,7 +26468,7 @@
           <p:cNvPr id="5" name="">
             <a:extLst xmlns:a="http://schemas.openxmlformats.org/drawingml/2006/main">
               <a:ext uri="{FF2B5EF4-FFF2-40B4-BE49-F238E27FC236}">
-                <a16:creationId xmlns:a16="http://schemas.microsoft.com/office/drawing/2014/main" id="{FD44D5DA-4A61-4139-8901-40B6642F26C3}"/>
+                <a16:creationId xmlns:a16="http://schemas.microsoft.com/office/drawing/2014/main" id="{F8E620C1-A7AE-49AC-B826-D73913CD8F82}"/>
               </a:ext>
             </a:extLst>
           </p:cNvPr>
@@ -26616,7 +26626,7 @@
           <p:cNvPr id="6" name="">
             <a:extLst xmlns:a="http://schemas.openxmlformats.org/drawingml/2006/main">
               <a:ext uri="{FF2B5EF4-FFF2-40B4-BE49-F238E27FC236}">
-                <a16:creationId xmlns:a16="http://schemas.microsoft.com/office/drawing/2014/main" id="{5B3C2EF8-D24D-4964-B38B-12FD6E091583}"/>
+                <a16:creationId xmlns:a16="http://schemas.microsoft.com/office/drawing/2014/main" id="{243CA880-2FD9-4CF0-B34F-B7321F4779AD}"/>
               </a:ext>
             </a:extLst>
           </p:cNvPr>
@@ -26772,7 +26782,7 @@
     </p:spTree>
     <p:extLst>
       <p:ext uri="{BB962C8B-B14F-4D97-AF65-F5344CB8AC3E}">
-        <p14:creationId xmlns:p14="http://schemas.microsoft.com/office/powerpoint/2010/main" val="439729376"/>
+        <p14:creationId xmlns:p14="http://schemas.microsoft.com/office/powerpoint/2010/main" val="1305520597"/>
       </p:ext>
     </p:extLst>
   </p:cSld>
@@ -26803,7 +26813,7 @@
           <p:cNvPr id="7" name="">
             <a:extLst xmlns:a="http://schemas.openxmlformats.org/drawingml/2006/main">
               <a:ext uri="{FF2B5EF4-FFF2-40B4-BE49-F238E27FC236}">
-                <a16:creationId xmlns:a16="http://schemas.microsoft.com/office/drawing/2014/main" id="{84BB6656-38B9-485D-B3E5-776D42210CCE}"/>
+                <a16:creationId xmlns:a16="http://schemas.microsoft.com/office/drawing/2014/main" id="{3ABA4296-D8F8-4125-8CB5-ADD7AB9A2079}"/>
               </a:ext>
             </a:extLst>
           </p:cNvPr>
@@ -26961,7 +26971,7 @@
           <p:cNvPr id="2" name="">
             <a:extLst xmlns:a="http://schemas.openxmlformats.org/drawingml/2006/main">
               <a:ext uri="{FF2B5EF4-FFF2-40B4-BE49-F238E27FC236}">
-                <a16:creationId xmlns:a16="http://schemas.microsoft.com/office/drawing/2014/main" id="{277A39CD-71A7-49AC-8E8E-3029D633CCDF}"/>
+                <a16:creationId xmlns:a16="http://schemas.microsoft.com/office/drawing/2014/main" id="{0020D8A5-70D9-4410-8D73-4109318A433E}"/>
               </a:ext>
             </a:extLst>
           </p:cNvPr>
@@ -27119,7 +27129,7 @@
           <p:cNvPr id="3" name="">
             <a:extLst xmlns:a="http://schemas.openxmlformats.org/drawingml/2006/main">
               <a:ext uri="{FF2B5EF4-FFF2-40B4-BE49-F238E27FC236}">
-                <a16:creationId xmlns:a16="http://schemas.microsoft.com/office/drawing/2014/main" id="{57D496BF-5A5F-4B03-BB2D-F0D54FC817D1}"/>
+                <a16:creationId xmlns:a16="http://schemas.microsoft.com/office/drawing/2014/main" id="{F80F8A8A-1097-40EF-A4D2-991F074F4B3C}"/>
               </a:ext>
             </a:extLst>
           </p:cNvPr>
@@ -27129,7 +27139,7 @@
           <p:nvPr/>
         </p:nvPicPr>
         <p:blipFill>
-          <a:blip xmlns:r="http://schemas.openxmlformats.org/officeDocument/2006/relationships" xmlns:a="http://schemas.openxmlformats.org/drawingml/2006/main" r:embed="R4248868f0188490b"/>
+          <a:blip xmlns:r="http://schemas.openxmlformats.org/officeDocument/2006/relationships" xmlns:a="http://schemas.openxmlformats.org/drawingml/2006/main" r:embed="R42d46d6bf43243df"/>
           <a:stretch xmlns:a="http://schemas.openxmlformats.org/drawingml/2006/main"/>
         </p:blipFill>
         <p:spPr>
@@ -27147,7 +27157,7 @@
           <p:cNvPr id="4" name="">
             <a:extLst xmlns:a="http://schemas.openxmlformats.org/drawingml/2006/main">
               <a:ext uri="{FF2B5EF4-FFF2-40B4-BE49-F238E27FC236}">
-                <a16:creationId xmlns:a16="http://schemas.microsoft.com/office/drawing/2014/main" id="{460AD358-62AD-4762-9C3F-5A2B440BA803}"/>
+                <a16:creationId xmlns:a16="http://schemas.microsoft.com/office/drawing/2014/main" id="{AC4BBE6E-1D64-412C-939B-B9D492D3C8B0}"/>
               </a:ext>
             </a:extLst>
           </p:cNvPr>
@@ -27333,7 +27343,7 @@
           <p:cNvPr id="5" name="">
             <a:extLst xmlns:a="http://schemas.openxmlformats.org/drawingml/2006/main">
               <a:ext uri="{FF2B5EF4-FFF2-40B4-BE49-F238E27FC236}">
-                <a16:creationId xmlns:a16="http://schemas.microsoft.com/office/drawing/2014/main" id="{1A8FA1B4-4723-4593-867D-54297869FEAF}"/>
+                <a16:creationId xmlns:a16="http://schemas.microsoft.com/office/drawing/2014/main" id="{C3375262-51C0-4C88-83AA-0980E0E98B10}"/>
               </a:ext>
             </a:extLst>
           </p:cNvPr>
@@ -27491,7 +27501,7 @@
           <p:cNvPr id="6" name="">
             <a:extLst xmlns:a="http://schemas.openxmlformats.org/drawingml/2006/main">
               <a:ext uri="{FF2B5EF4-FFF2-40B4-BE49-F238E27FC236}">
-                <a16:creationId xmlns:a16="http://schemas.microsoft.com/office/drawing/2014/main" id="{0EC97246-F517-4906-B880-A7B969E411A2}"/>
+                <a16:creationId xmlns:a16="http://schemas.microsoft.com/office/drawing/2014/main" id="{36F50BBD-56A3-4DBD-8669-3D455A50F925}"/>
               </a:ext>
             </a:extLst>
           </p:cNvPr>
@@ -27647,7 +27657,7 @@
     </p:spTree>
     <p:extLst>
       <p:ext uri="{BB962C8B-B14F-4D97-AF65-F5344CB8AC3E}">
-        <p14:creationId xmlns:p14="http://schemas.microsoft.com/office/powerpoint/2010/main" val="1545772463"/>
+        <p14:creationId xmlns:p14="http://schemas.microsoft.com/office/powerpoint/2010/main" val="212282922"/>
       </p:ext>
     </p:extLst>
   </p:cSld>
@@ -27678,7 +27688,7 @@
           <p:cNvPr id="7" name="">
             <a:extLst xmlns:a="http://schemas.openxmlformats.org/drawingml/2006/main">
               <a:ext uri="{FF2B5EF4-FFF2-40B4-BE49-F238E27FC236}">
-                <a16:creationId xmlns:a16="http://schemas.microsoft.com/office/drawing/2014/main" id="{A11FB0BB-3A57-4066-9244-87B970148E6D}"/>
+                <a16:creationId xmlns:a16="http://schemas.microsoft.com/office/drawing/2014/main" id="{85825F38-4869-4746-B5E4-94BC16E2DC31}"/>
               </a:ext>
             </a:extLst>
           </p:cNvPr>
@@ -27836,7 +27846,7 @@
           <p:cNvPr id="2" name="">
             <a:extLst xmlns:a="http://schemas.openxmlformats.org/drawingml/2006/main">
               <a:ext uri="{FF2B5EF4-FFF2-40B4-BE49-F238E27FC236}">
-                <a16:creationId xmlns:a16="http://schemas.microsoft.com/office/drawing/2014/main" id="{596CA215-B6B5-470D-8074-C57B5F46C1F3}"/>
+                <a16:creationId xmlns:a16="http://schemas.microsoft.com/office/drawing/2014/main" id="{5108E41D-091B-482A-ABD1-72F91CF1DE32}"/>
               </a:ext>
             </a:extLst>
           </p:cNvPr>
@@ -27994,7 +28004,7 @@
           <p:cNvPr id="3" name="">
             <a:extLst xmlns:a="http://schemas.openxmlformats.org/drawingml/2006/main">
               <a:ext uri="{FF2B5EF4-FFF2-40B4-BE49-F238E27FC236}">
-                <a16:creationId xmlns:a16="http://schemas.microsoft.com/office/drawing/2014/main" id="{C30EB0AF-DF4C-4E15-ACB5-2216F8ADE2B7}"/>
+                <a16:creationId xmlns:a16="http://schemas.microsoft.com/office/drawing/2014/main" id="{847BAADB-7759-4A52-B10A-96E27368DE70}"/>
               </a:ext>
             </a:extLst>
           </p:cNvPr>
@@ -28004,7 +28014,7 @@
           <p:nvPr/>
         </p:nvPicPr>
         <p:blipFill>
-          <a:blip xmlns:r="http://schemas.openxmlformats.org/officeDocument/2006/relationships" xmlns:a="http://schemas.openxmlformats.org/drawingml/2006/main" r:embed="Re8d10cb838794faa"/>
+          <a:blip xmlns:r="http://schemas.openxmlformats.org/officeDocument/2006/relationships" xmlns:a="http://schemas.openxmlformats.org/drawingml/2006/main" r:embed="R43ad66abd9964a96"/>
           <a:stretch xmlns:a="http://schemas.openxmlformats.org/drawingml/2006/main"/>
         </p:blipFill>
         <p:spPr>
@@ -28022,7 +28032,7 @@
           <p:cNvPr id="4" name="">
             <a:extLst xmlns:a="http://schemas.openxmlformats.org/drawingml/2006/main">
               <a:ext uri="{FF2B5EF4-FFF2-40B4-BE49-F238E27FC236}">
-                <a16:creationId xmlns:a16="http://schemas.microsoft.com/office/drawing/2014/main" id="{0A0D6327-534D-467C-A571-08168E10F0F0}"/>
+                <a16:creationId xmlns:a16="http://schemas.microsoft.com/office/drawing/2014/main" id="{5B05A0A7-9A56-44A9-ABC7-8C571AA5C102}"/>
               </a:ext>
             </a:extLst>
           </p:cNvPr>
@@ -28208,7 +28218,7 @@
           <p:cNvPr id="5" name="">
             <a:extLst xmlns:a="http://schemas.openxmlformats.org/drawingml/2006/main">
               <a:ext uri="{FF2B5EF4-FFF2-40B4-BE49-F238E27FC236}">
-                <a16:creationId xmlns:a16="http://schemas.microsoft.com/office/drawing/2014/main" id="{81D6C18A-4FF5-412C-9C5F-42BA99CC809D}"/>
+                <a16:creationId xmlns:a16="http://schemas.microsoft.com/office/drawing/2014/main" id="{4D56D776-43E3-4251-B077-12B908B6ED63}"/>
               </a:ext>
             </a:extLst>
           </p:cNvPr>
@@ -28366,7 +28376,7 @@
           <p:cNvPr id="6" name="">
             <a:extLst xmlns:a="http://schemas.openxmlformats.org/drawingml/2006/main">
               <a:ext uri="{FF2B5EF4-FFF2-40B4-BE49-F238E27FC236}">
-                <a16:creationId xmlns:a16="http://schemas.microsoft.com/office/drawing/2014/main" id="{A4A86585-44F7-4D98-BFD8-2FD4CBFED705}"/>
+                <a16:creationId xmlns:a16="http://schemas.microsoft.com/office/drawing/2014/main" id="{F64A46B9-8A20-4763-A799-D8702C103C2C}"/>
               </a:ext>
             </a:extLst>
           </p:cNvPr>
@@ -28522,7 +28532,7 @@
     </p:spTree>
     <p:extLst>
       <p:ext uri="{BB962C8B-B14F-4D97-AF65-F5344CB8AC3E}">
-        <p14:creationId xmlns:p14="http://schemas.microsoft.com/office/powerpoint/2010/main" val="1397578282"/>
+        <p14:creationId xmlns:p14="http://schemas.microsoft.com/office/powerpoint/2010/main" val="1756408146"/>
       </p:ext>
     </p:extLst>
   </p:cSld>
@@ -28553,7 +28563,7 @@
           <p:cNvPr id="7" name="">
             <a:extLst xmlns:a="http://schemas.openxmlformats.org/drawingml/2006/main">
               <a:ext uri="{FF2B5EF4-FFF2-40B4-BE49-F238E27FC236}">
-                <a16:creationId xmlns:a16="http://schemas.microsoft.com/office/drawing/2014/main" id="{78843F43-AAC2-41FD-B82E-D25E3F3D26D6}"/>
+                <a16:creationId xmlns:a16="http://schemas.microsoft.com/office/drawing/2014/main" id="{7FEDA219-2EFB-422B-AD29-F036BFE70D66}"/>
               </a:ext>
             </a:extLst>
           </p:cNvPr>
@@ -28711,7 +28721,7 @@
           <p:cNvPr id="2" name="">
             <a:extLst xmlns:a="http://schemas.openxmlformats.org/drawingml/2006/main">
               <a:ext uri="{FF2B5EF4-FFF2-40B4-BE49-F238E27FC236}">
-                <a16:creationId xmlns:a16="http://schemas.microsoft.com/office/drawing/2014/main" id="{32648462-73A1-4FE6-8EE6-6C2421F6E102}"/>
+                <a16:creationId xmlns:a16="http://schemas.microsoft.com/office/drawing/2014/main" id="{4D7C4275-7D6A-4D76-B693-A5A76420C817}"/>
               </a:ext>
             </a:extLst>
           </p:cNvPr>
@@ -28869,7 +28879,7 @@
           <p:cNvPr id="3" name="">
             <a:extLst xmlns:a="http://schemas.openxmlformats.org/drawingml/2006/main">
               <a:ext uri="{FF2B5EF4-FFF2-40B4-BE49-F238E27FC236}">
-                <a16:creationId xmlns:a16="http://schemas.microsoft.com/office/drawing/2014/main" id="{417875DE-0965-47D5-B74A-5DDBF5D3137E}"/>
+                <a16:creationId xmlns:a16="http://schemas.microsoft.com/office/drawing/2014/main" id="{186691BE-5D88-4362-86A2-40CF8E1B7FCA}"/>
               </a:ext>
             </a:extLst>
           </p:cNvPr>
@@ -28879,7 +28889,7 @@
           <p:nvPr/>
         </p:nvPicPr>
         <p:blipFill>
-          <a:blip xmlns:r="http://schemas.openxmlformats.org/officeDocument/2006/relationships" xmlns:a="http://schemas.openxmlformats.org/drawingml/2006/main" r:embed="R0a6d58b920014b1a"/>
+          <a:blip xmlns:r="http://schemas.openxmlformats.org/officeDocument/2006/relationships" xmlns:a="http://schemas.openxmlformats.org/drawingml/2006/main" r:embed="Rf7309bc1b985499e"/>
           <a:stretch xmlns:a="http://schemas.openxmlformats.org/drawingml/2006/main"/>
         </p:blipFill>
         <p:spPr>
@@ -28897,7 +28907,7 @@
           <p:cNvPr id="4" name="">
             <a:extLst xmlns:a="http://schemas.openxmlformats.org/drawingml/2006/main">
               <a:ext uri="{FF2B5EF4-FFF2-40B4-BE49-F238E27FC236}">
-                <a16:creationId xmlns:a16="http://schemas.microsoft.com/office/drawing/2014/main" id="{18E65650-DA9E-4A53-8495-7896CD92AE2E}"/>
+                <a16:creationId xmlns:a16="http://schemas.microsoft.com/office/drawing/2014/main" id="{49D9F2CD-F87A-4B39-A35F-977E95FF4FB3}"/>
               </a:ext>
             </a:extLst>
           </p:cNvPr>
@@ -29083,7 +29093,7 @@
           <p:cNvPr id="5" name="">
             <a:extLst xmlns:a="http://schemas.openxmlformats.org/drawingml/2006/main">
               <a:ext uri="{FF2B5EF4-FFF2-40B4-BE49-F238E27FC236}">
-                <a16:creationId xmlns:a16="http://schemas.microsoft.com/office/drawing/2014/main" id="{98EDD59E-C09A-498F-B29D-10091A09EB8A}"/>
+                <a16:creationId xmlns:a16="http://schemas.microsoft.com/office/drawing/2014/main" id="{ACA0E3C6-9345-4EC4-BD09-2E244EBAD794}"/>
               </a:ext>
             </a:extLst>
           </p:cNvPr>
@@ -29241,7 +29251,7 @@
           <p:cNvPr id="6" name="">
             <a:extLst xmlns:a="http://schemas.openxmlformats.org/drawingml/2006/main">
               <a:ext uri="{FF2B5EF4-FFF2-40B4-BE49-F238E27FC236}">
-                <a16:creationId xmlns:a16="http://schemas.microsoft.com/office/drawing/2014/main" id="{47C2675D-7F9E-49B6-A16E-88BF930A3176}"/>
+                <a16:creationId xmlns:a16="http://schemas.microsoft.com/office/drawing/2014/main" id="{BB66F8ED-375A-4078-AAAC-623440B3746B}"/>
               </a:ext>
             </a:extLst>
           </p:cNvPr>
@@ -29397,7 +29407,7 @@
     </p:spTree>
     <p:extLst>
       <p:ext uri="{BB962C8B-B14F-4D97-AF65-F5344CB8AC3E}">
-        <p14:creationId xmlns:p14="http://schemas.microsoft.com/office/powerpoint/2010/main" val="2027004654"/>
+        <p14:creationId xmlns:p14="http://schemas.microsoft.com/office/powerpoint/2010/main" val="920255653"/>
       </p:ext>
     </p:extLst>
   </p:cSld>

</xml_diff>